<commit_message>
updates to presentation files
</commit_message>
<xml_diff>
--- a/files/presentation.pptx
+++ b/files/presentation.pptx
@@ -4,6 +4,9 @@
   <p:sldMasterIdLst>
     <p:sldMasterId id="2147483648" r:id="rId1"/>
   </p:sldMasterIdLst>
+  <p:notesMasterIdLst>
+    <p:notesMasterId r:id="rId9"/>
+  </p:notesMasterIdLst>
   <p:sldIdLst>
     <p:sldId id="256" r:id="rId2"/>
     <p:sldId id="257" r:id="rId3"/>
@@ -13,10 +16,7 @@
     <p:sldId id="261" r:id="rId7"/>
     <p:sldId id="262" r:id="rId8"/>
   </p:sldIdLst>
-  <p:notesMasterIdLst>
-    <p:notesMasterId r:id="rId9"/>
-  </p:notesMasterIdLst>
-  <p:sldSz cx="9144000" cy="5143500"/>
+  <p:sldSz cx="9144000" cy="5143500" type="screen16x9"/>
   <p:notesSz cx="5143500" cy="9144000"/>
   <p:defaultTextStyle>
     <a:lvl1pPr marL="0" algn="l" defTabSz="914400" rtl="0" eaLnBrk="1" latinLnBrk="0" hangingPunct="1">
@@ -110,6 +110,11 @@
       </a:defRPr>
     </a:lvl9pPr>
   </p:defaultTextStyle>
+  <p:extLst>
+    <p:ext uri="{EFAFB233-063F-42B5-8137-9DF3F51BA10A}">
+      <p15:sldGuideLst xmlns:p15="http://schemas.microsoft.com/office/powerpoint/2012/main"/>
+    </p:ext>
+  </p:extLst>
 </p:presentation>
 </file>
 
@@ -135,234 +140,10 @@
           <a:chExt cx="0" cy="0"/>
         </a:xfrm>
       </p:grpSpPr>
-      <p:sp>
-        <p:nvSpPr>
-          <p:cNvPr id="2" name="Header Placeholder 1"/>
-          <p:cNvSpPr>
-            <a:spLocks noGrp="1"/>
-          </p:cNvSpPr>
-          <p:nvPr>
-            <p:ph type="hdr" sz="quarter"/>
-          </p:nvPr>
-        </p:nvSpPr>
-        <p:spPr>
-          <a:xfrm>
-            <a:off x="0" y="0"/>
-            <a:ext cx="2971800" cy="458788"/>
-          </a:xfrm>
-          <a:prstGeom prst="rect">
-            <a:avLst/>
-          </a:prstGeom>
-        </p:spPr>
-        <p:txBody>
-          <a:bodyPr vert="horz" lIns="91440" tIns="45720" rIns="91440" bIns="45720" rtlCol="0"/>
-          <a:lstStyle>
-            <a:lvl1pPr algn="l">
-              <a:defRPr sz="1200"/>
-            </a:lvl1pPr>
-          </a:lstStyle>
-          <a:p>
-            <a:endParaRPr lang="en-US"/>
-          </a:p>
-        </p:txBody>
-      </p:sp>
-      <p:sp>
-        <p:nvSpPr>
-          <p:cNvPr id="3" name="Date Placeholder 2"/>
-          <p:cNvSpPr>
-            <a:spLocks noGrp="1"/>
-          </p:cNvSpPr>
-          <p:nvPr>
-            <p:ph type="dt" idx="1"/>
-          </p:nvPr>
-        </p:nvSpPr>
-        <p:spPr>
-          <a:xfrm>
-            <a:off x="3884613" y="0"/>
-            <a:ext cx="2971800" cy="458788"/>
-          </a:xfrm>
-          <a:prstGeom prst="rect">
-            <a:avLst/>
-          </a:prstGeom>
-        </p:spPr>
-        <p:txBody>
-          <a:bodyPr vert="horz" lIns="91440" tIns="45720" rIns="91440" bIns="45720" rtlCol="0"/>
-          <a:lstStyle>
-            <a:lvl1pPr algn="r">
-              <a:defRPr sz="1200"/>
-            </a:lvl1pPr>
-          </a:lstStyle>
-          <a:p>
-            <a:fld id="{5282F153-3F37-0F45-9E97-73ACFA13230C}" type="datetimeFigureOut">
-              <a:rPr lang="en-US"/>
-              <a:t>7/23/19</a:t>
-            </a:fld>
-            <a:endParaRPr lang="en-US"/>
-          </a:p>
-        </p:txBody>
-      </p:sp>
-      <p:sp>
-        <p:nvSpPr>
-          <p:cNvPr id="4" name="Slide Image Placeholder 3"/>
-          <p:cNvSpPr>
-            <a:spLocks noGrp="1" noRot="1" noChangeAspect="1"/>
-          </p:cNvSpPr>
-          <p:nvPr>
-            <p:ph type="sldImg" idx="2"/>
-          </p:nvPr>
-        </p:nvSpPr>
-        <p:spPr>
-          <a:xfrm>
-            <a:off x="685800" y="1143000"/>
-            <a:ext cx="5486400" cy="3086100"/>
-          </a:xfrm>
-          <a:prstGeom prst="rect">
-            <a:avLst/>
-          </a:prstGeom>
-          <a:noFill/>
-          <a:ln w="12700">
-            <a:solidFill>
-              <a:prstClr val="black"/>
-            </a:solidFill>
-          </a:ln>
-        </p:spPr>
-        <p:txBody>
-          <a:bodyPr vert="horz" lIns="91440" tIns="45720" rIns="91440" bIns="45720" rtlCol="0" anchor="ctr"/>
-          <a:lstStyle/>
-          <a:p>
-            <a:endParaRPr lang="en-US"/>
-          </a:p>
-        </p:txBody>
-      </p:sp>
-      <p:sp>
-        <p:nvSpPr>
-          <p:cNvPr id="5" name="Notes Placeholder 4"/>
-          <p:cNvSpPr>
-            <a:spLocks noGrp="1"/>
-          </p:cNvSpPr>
-          <p:nvPr>
-            <p:ph type="body" sz="quarter" idx="3"/>
-          </p:nvPr>
-        </p:nvSpPr>
-        <p:spPr>
-          <a:xfrm>
-            <a:off x="685800" y="4400550"/>
-            <a:ext cx="5486400" cy="3600450"/>
-          </a:xfrm>
-          <a:prstGeom prst="rect">
-            <a:avLst/>
-          </a:prstGeom>
-        </p:spPr>
-        <p:txBody>
-          <a:bodyPr vert="horz" lIns="91440" tIns="45720" rIns="91440" bIns="45720" rtlCol="0"/>
-          <a:lstStyle/>
-          <a:p>
-            <a:pPr lvl="0"/>
-            <a:r>
-              <a:rPr lang="en-US"/>
-              <a:t>Click to edit Master text styles</a:t>
-            </a:r>
-          </a:p>
-          <a:p>
-            <a:pPr lvl="1"/>
-            <a:r>
-              <a:rPr lang="en-US"/>
-              <a:t>Second level</a:t>
-            </a:r>
-          </a:p>
-          <a:p>
-            <a:pPr lvl="2"/>
-            <a:r>
-              <a:rPr lang="en-US"/>
-              <a:t>Third level</a:t>
-            </a:r>
-          </a:p>
-          <a:p>
-            <a:pPr lvl="3"/>
-            <a:r>
-              <a:rPr lang="en-US"/>
-              <a:t>Fourth level</a:t>
-            </a:r>
-          </a:p>
-          <a:p>
-            <a:pPr lvl="4"/>
-            <a:r>
-              <a:rPr lang="en-US"/>
-              <a:t>Fifth level</a:t>
-            </a:r>
-          </a:p>
-        </p:txBody>
-      </p:sp>
-      <p:sp>
-        <p:nvSpPr>
-          <p:cNvPr id="6" name="Footer Placeholder 5"/>
-          <p:cNvSpPr>
-            <a:spLocks noGrp="1"/>
-          </p:cNvSpPr>
-          <p:nvPr>
-            <p:ph type="ftr" sz="quarter" idx="4"/>
-          </p:nvPr>
-        </p:nvSpPr>
-        <p:spPr>
-          <a:xfrm>
-            <a:off x="0" y="8685213"/>
-            <a:ext cx="2971800" cy="458787"/>
-          </a:xfrm>
-          <a:prstGeom prst="rect">
-            <a:avLst/>
-          </a:prstGeom>
-        </p:spPr>
-        <p:txBody>
-          <a:bodyPr vert="horz" lIns="91440" tIns="45720" rIns="91440" bIns="45720" rtlCol="0" anchor="b"/>
-          <a:lstStyle>
-            <a:lvl1pPr algn="l">
-              <a:defRPr sz="1200"/>
-            </a:lvl1pPr>
-          </a:lstStyle>
-          <a:p>
-            <a:endParaRPr lang="en-US"/>
-          </a:p>
-        </p:txBody>
-      </p:sp>
-      <p:sp>
-        <p:nvSpPr>
-          <p:cNvPr id="7" name="Slide Number Placeholder 6"/>
-          <p:cNvSpPr>
-            <a:spLocks noGrp="1"/>
-          </p:cNvSpPr>
-          <p:nvPr>
-            <p:ph type="sldNum" sz="quarter" idx="5"/>
-          </p:nvPr>
-        </p:nvSpPr>
-        <p:spPr>
-          <a:xfrm>
-            <a:off x="3884613" y="8685213"/>
-            <a:ext cx="2971800" cy="458787"/>
-          </a:xfrm>
-          <a:prstGeom prst="rect">
-            <a:avLst/>
-          </a:prstGeom>
-        </p:spPr>
-        <p:txBody>
-          <a:bodyPr vert="horz" lIns="91440" tIns="45720" rIns="91440" bIns="45720" rtlCol="0" anchor="b"/>
-          <a:lstStyle>
-            <a:lvl1pPr algn="r">
-              <a:defRPr sz="1200"/>
-            </a:lvl1pPr>
-          </a:lstStyle>
-          <a:p>
-            <a:fld id="{CE5E9CC1-C706-0F49-92D6-E571CC5EEA8F}" type="slidenum">
-              <a:rPr lang="en-US"/>
-              <a:t>‹#›</a:t>
-            </a:fld>
-            <a:endParaRPr lang="en-US"/>
-          </a:p>
-        </p:txBody>
-      </p:sp>
     </p:spTree>
     <p:extLst>
       <p:ext uri="{BB962C8B-B14F-4D97-AF65-F5344CB8AC3E}">
-        <p14:creationId xmlns:p14="http://schemas.microsoft.com/office/powerpoint/2010/main" val="1024086991"/>
+        <p14:creationId xmlns:p14="http://schemas.microsoft.com/office/powerpoint/2010/main" val="1750534100"/>
       </p:ext>
     </p:extLst>
   </p:cSld>
@@ -506,10 +287,6 @@
           <a:bodyPr/>
           <a:lstStyle/>
           <a:p>
-            <a:r>
-              <a:rPr lang="en-US" dirty="0"/>
-              <a:t/>
-            </a:r>
             <a:endParaRPr lang="en-US" dirty="0"/>
           </a:p>
         </p:txBody>
@@ -594,10 +371,6 @@
           <a:bodyPr/>
           <a:lstStyle/>
           <a:p>
-            <a:r>
-              <a:rPr lang="en-US" dirty="0"/>
-              <a:t/>
-            </a:r>
             <a:endParaRPr lang="en-US" dirty="0"/>
           </a:p>
         </p:txBody>
@@ -682,10 +455,6 @@
           <a:bodyPr/>
           <a:lstStyle/>
           <a:p>
-            <a:r>
-              <a:rPr lang="en-US" dirty="0"/>
-              <a:t/>
-            </a:r>
             <a:endParaRPr lang="en-US" dirty="0"/>
           </a:p>
         </p:txBody>
@@ -770,10 +539,6 @@
           <a:bodyPr/>
           <a:lstStyle/>
           <a:p>
-            <a:r>
-              <a:rPr lang="en-US" dirty="0"/>
-              <a:t/>
-            </a:r>
             <a:endParaRPr lang="en-US" dirty="0"/>
           </a:p>
         </p:txBody>
@@ -858,10 +623,6 @@
           <a:bodyPr/>
           <a:lstStyle/>
           <a:p>
-            <a:r>
-              <a:rPr lang="en-US" dirty="0"/>
-              <a:t/>
-            </a:r>
             <a:endParaRPr lang="en-US" dirty="0"/>
           </a:p>
         </p:txBody>
@@ -946,10 +707,6 @@
           <a:bodyPr/>
           <a:lstStyle/>
           <a:p>
-            <a:r>
-              <a:rPr lang="en-US" dirty="0"/>
-              <a:t/>
-            </a:r>
             <a:endParaRPr lang="en-US" dirty="0"/>
           </a:p>
         </p:txBody>
@@ -1034,10 +791,6 @@
           <a:bodyPr/>
           <a:lstStyle/>
           <a:p>
-            <a:r>
-              <a:rPr lang="en-US" dirty="0"/>
-              <a:t/>
-            </a:r>
             <a:endParaRPr lang="en-US" dirty="0"/>
           </a:p>
         </p:txBody>
@@ -1111,6 +864,11 @@
 <file path=ppt/slideMasters/slideMaster1.xml><?xml version="1.0" encoding="utf-8"?>
 <p:sldMaster xmlns:a="http://schemas.openxmlformats.org/drawingml/2006/main" xmlns:r="http://schemas.openxmlformats.org/officeDocument/2006/relationships" xmlns:p="http://schemas.openxmlformats.org/presentationml/2006/main">
   <p:cSld>
+    <p:bg>
+      <p:bgRef idx="1001">
+        <a:schemeClr val="bg1"/>
+      </p:bgRef>
+    </p:bg>
     <p:spTree>
       <p:nvGrpSpPr>
         <p:cNvPr id="1" name=""/>
@@ -1393,6 +1151,7 @@
         <a:solidFill>
           <a:srgbClr val="0D1B2A"/>
         </a:solidFill>
+        <a:effectLst/>
       </p:bgPr>
     </p:bg>
     <p:spTree>
@@ -1435,6 +1194,13 @@
             <a:prstDash val="solid"/>
           </a:ln>
         </p:spPr>
+        <p:txBody>
+          <a:bodyPr/>
+          <a:lstStyle/>
+          <a:p>
+            <a:endParaRPr lang="en-US"/>
+          </a:p>
+        </p:txBody>
       </p:sp>
       <p:sp>
         <p:nvSpPr>
@@ -1457,7 +1223,7 @@
           <a:bodyPr wrap="square" rtlCol="0" anchor="ctr"/>
           <a:lstStyle/>
           <a:p>
-            <a:pPr algn="ctr" indent="0" marL="0">
+            <a:pPr marL="0" indent="0" algn="ctr">
               <a:buNone/>
             </a:pPr>
             <a:r>
@@ -1493,7 +1259,7 @@
           <a:bodyPr wrap="square" lIns="0" tIns="0" rIns="0" bIns="0" rtlCol="0" anchor="ctr"/>
           <a:lstStyle/>
           <a:p>
-            <a:pPr algn="l" indent="0" marL="0">
+            <a:pPr marL="0" indent="0" algn="l">
               <a:buNone/>
             </a:pPr>
             <a:r>
@@ -1532,7 +1298,7 @@
           <a:bodyPr wrap="square" lIns="0" tIns="0" rIns="0" bIns="0" rtlCol="0" anchor="ctr"/>
           <a:lstStyle/>
           <a:p>
-            <a:pPr algn="l" indent="0" marL="0">
+            <a:pPr marL="0" indent="0" algn="l">
               <a:buNone/>
             </a:pPr>
             <a:r>
@@ -1574,6 +1340,13 @@
             <a:prstDash val="solid"/>
           </a:ln>
         </p:spPr>
+        <p:txBody>
+          <a:bodyPr/>
+          <a:lstStyle/>
+          <a:p>
+            <a:endParaRPr lang="en-US"/>
+          </a:p>
+        </p:txBody>
       </p:sp>
       <p:sp>
         <p:nvSpPr>
@@ -1596,7 +1369,7 @@
           <a:bodyPr wrap="square" lIns="0" tIns="0" rIns="0" bIns="0" rtlCol="0" anchor="ctr"/>
           <a:lstStyle/>
           <a:p>
-            <a:pPr algn="l" indent="0" marL="0">
+            <a:pPr marL="0" indent="0" algn="l">
               <a:buNone/>
             </a:pPr>
             <a:r>
@@ -1635,7 +1408,7 @@
           <a:bodyPr wrap="square" lIns="0" tIns="0" rIns="0" bIns="0" rtlCol="0" anchor="ctr"/>
           <a:lstStyle/>
           <a:p>
-            <a:pPr algn="l" indent="0" marL="0">
+            <a:pPr marL="0" indent="0" algn="l">
               <a:buNone/>
             </a:pPr>
             <a:r>
@@ -1669,6 +1442,7 @@
         <a:solidFill>
           <a:srgbClr val="E8F1F8"/>
         </a:solidFill>
+        <a:effectLst/>
       </p:bgPr>
     </p:bg>
     <p:spTree>
@@ -1706,7 +1480,7 @@
           <a:bodyPr wrap="square" lIns="0" tIns="0" rIns="0" bIns="0" rtlCol="0" anchor="ctr"/>
           <a:lstStyle/>
           <a:p>
-            <a:pPr indent="0" marL="0">
+            <a:pPr marL="0" indent="0">
               <a:buNone/>
             </a:pPr>
             <a:r>
@@ -1748,6 +1522,13 @@
             <a:prstDash val="solid"/>
           </a:ln>
         </p:spPr>
+        <p:txBody>
+          <a:bodyPr/>
+          <a:lstStyle/>
+          <a:p>
+            <a:endParaRPr lang="en-US"/>
+          </a:p>
+        </p:txBody>
       </p:sp>
       <p:sp>
         <p:nvSpPr>
@@ -1773,13 +1554,20 @@
             <a:prstDash val="solid"/>
           </a:ln>
           <a:effectLst>
-            <a:outerShdw sx="100000" sy="100000" kx="0" ky="0" algn="bl" rotWithShape="0" blurRad="101600" dist="25400" dir="8100000">
+            <a:outerShdw blurRad="101600" dist="25400" dir="8100000" algn="bl" rotWithShape="0">
               <a:srgbClr val="000000">
                 <a:alpha val="10000"/>
               </a:srgbClr>
             </a:outerShdw>
           </a:effectLst>
         </p:spPr>
+        <p:txBody>
+          <a:bodyPr/>
+          <a:lstStyle/>
+          <a:p>
+            <a:endParaRPr lang="en-US"/>
+          </a:p>
+        </p:txBody>
       </p:sp>
       <p:sp>
         <p:nvSpPr>
@@ -1802,7 +1590,7 @@
           <a:bodyPr wrap="square" lIns="0" tIns="0" rIns="0" bIns="0" rtlCol="0" anchor="ctr"/>
           <a:lstStyle/>
           <a:p>
-            <a:pPr indent="0" marL="0">
+            <a:pPr marL="0" indent="0">
               <a:buNone/>
             </a:pPr>
             <a:r>
@@ -1841,7 +1629,7 @@
           <a:bodyPr wrap="square" lIns="0" tIns="0" rIns="0" bIns="0" rtlCol="0" anchor="t"/>
           <a:lstStyle/>
           <a:p>
-            <a:pPr indent="0" marL="0">
+            <a:pPr marL="0" indent="0">
               <a:buNone/>
             </a:pPr>
             <a:r>
@@ -1855,9 +1643,6 @@
               </a:rPr>
               <a:t>You want to fly from </a:t>
             </a:r>
-            <a:pPr indent="0" marL="0">
-              <a:buNone/>
-            </a:pPr>
             <a:r>
               <a:rPr lang="en-US" sz="1300" b="1" dirty="0">
                 <a:solidFill>
@@ -1869,9 +1654,6 @@
               </a:rPr>
               <a:t>Washington D.C.</a:t>
             </a:r>
-            <a:pPr indent="0" marL="0">
-              <a:buNone/>
-            </a:pPr>
             <a:r>
               <a:rPr lang="en-US" sz="1300" dirty="0">
                 <a:solidFill>
@@ -1883,9 +1665,6 @@
               </a:rPr>
               <a:t> to </a:t>
             </a:r>
-            <a:pPr indent="0" marL="0">
-              <a:buNone/>
-            </a:pPr>
             <a:r>
               <a:rPr lang="en-US" sz="1300" b="1" dirty="0">
                 <a:solidFill>
@@ -1897,19 +1676,16 @@
               </a:rPr>
               <a:t>Tokyo, Japan.</a:t>
             </a:r>
-            <a:pPr indent="0" marL="0">
-              <a:buNone/>
-            </a:pPr>
             <a:endParaRPr lang="en-US" sz="1300" dirty="0"/>
           </a:p>
           <a:p>
-            <a:pPr indent="0" marL="0">
+            <a:pPr marL="0" indent="0">
               <a:buNone/>
             </a:pPr>
             <a:endParaRPr lang="en-US" sz="1300" dirty="0"/>
           </a:p>
           <a:p>
-            <a:pPr indent="0" marL="0">
+            <a:pPr marL="0" indent="0">
               <a:buNone/>
             </a:pPr>
             <a:r>
@@ -1926,19 +1702,19 @@
             <a:endParaRPr lang="en-US" sz="1300" dirty="0"/>
           </a:p>
           <a:p>
-            <a:pPr indent="0" marL="0">
+            <a:pPr marL="0" indent="0">
               <a:buNone/>
             </a:pPr>
             <a:endParaRPr lang="en-US" sz="1300" dirty="0"/>
           </a:p>
           <a:p>
-            <a:pPr indent="0" marL="0">
+            <a:pPr marL="0" indent="0">
               <a:buNone/>
             </a:pPr>
             <a:endParaRPr lang="en-US" sz="1300" dirty="0"/>
           </a:p>
           <a:p>
-            <a:pPr indent="0" marL="0">
+            <a:pPr marL="0" indent="0">
               <a:buNone/>
             </a:pPr>
             <a:r>
@@ -1980,13 +1756,20 @@
             <a:prstDash val="solid"/>
           </a:ln>
           <a:effectLst>
-            <a:outerShdw sx="100000" sy="100000" kx="0" ky="0" algn="bl" rotWithShape="0" blurRad="101600" dist="25400" dir="8100000">
+            <a:outerShdw blurRad="101600" dist="25400" dir="8100000" algn="bl" rotWithShape="0">
               <a:srgbClr val="000000">
                 <a:alpha val="10000"/>
               </a:srgbClr>
             </a:outerShdw>
           </a:effectLst>
         </p:spPr>
+        <p:txBody>
+          <a:bodyPr/>
+          <a:lstStyle/>
+          <a:p>
+            <a:endParaRPr lang="en-US"/>
+          </a:p>
+        </p:txBody>
       </p:sp>
       <p:sp>
         <p:nvSpPr>
@@ -2009,7 +1792,7 @@
           <a:bodyPr wrap="square" lIns="0" tIns="0" rIns="0" bIns="0" rtlCol="0" anchor="ctr"/>
           <a:lstStyle/>
           <a:p>
-            <a:pPr indent="0" marL="0">
+            <a:pPr marL="0" indent="0">
               <a:buNone/>
             </a:pPr>
             <a:r>
@@ -2051,6 +1834,13 @@
             <a:prstDash val="solid"/>
           </a:ln>
         </p:spPr>
+        <p:txBody>
+          <a:bodyPr/>
+          <a:lstStyle/>
+          <a:p>
+            <a:endParaRPr lang="en-US"/>
+          </a:p>
+        </p:txBody>
       </p:sp>
       <p:sp>
         <p:nvSpPr>
@@ -2073,7 +1863,7 @@
           <a:bodyPr wrap="square" lIns="0" tIns="0" rIns="0" bIns="0" rtlCol="0" anchor="ctr"/>
           <a:lstStyle/>
           <a:p>
-            <a:pPr indent="0" marL="0">
+            <a:pPr marL="0" indent="0">
               <a:buNone/>
             </a:pPr>
             <a:r>
@@ -2112,7 +1902,7 @@
           <a:bodyPr wrap="square" lIns="0" tIns="0" rIns="0" bIns="0" rtlCol="0" anchor="ctr"/>
           <a:lstStyle/>
           <a:p>
-            <a:pPr indent="0" marL="0">
+            <a:pPr marL="0" indent="0">
               <a:buNone/>
             </a:pPr>
             <a:r>
@@ -2154,6 +1944,13 @@
             <a:prstDash val="solid"/>
           </a:ln>
         </p:spPr>
+        <p:txBody>
+          <a:bodyPr/>
+          <a:lstStyle/>
+          <a:p>
+            <a:endParaRPr lang="en-US"/>
+          </a:p>
+        </p:txBody>
       </p:sp>
       <p:sp>
         <p:nvSpPr>
@@ -2176,7 +1973,7 @@
           <a:bodyPr wrap="square" lIns="0" tIns="0" rIns="0" bIns="0" rtlCol="0" anchor="ctr"/>
           <a:lstStyle/>
           <a:p>
-            <a:pPr indent="0" marL="0">
+            <a:pPr marL="0" indent="0">
               <a:buNone/>
             </a:pPr>
             <a:r>
@@ -2215,7 +2012,7 @@
           <a:bodyPr wrap="square" lIns="0" tIns="0" rIns="0" bIns="0" rtlCol="0" anchor="ctr"/>
           <a:lstStyle/>
           <a:p>
-            <a:pPr indent="0" marL="0">
+            <a:pPr marL="0" indent="0">
               <a:buNone/>
             </a:pPr>
             <a:r>
@@ -2254,7 +2051,7 @@
           <a:bodyPr wrap="square" lIns="0" tIns="0" rIns="0" bIns="0" rtlCol="0" anchor="ctr"/>
           <a:lstStyle/>
           <a:p>
-            <a:pPr indent="0" marL="0">
+            <a:pPr marL="0" indent="0">
               <a:buNone/>
             </a:pPr>
             <a:r>
@@ -2288,6 +2085,7 @@
         <a:solidFill>
           <a:srgbClr val="0D1B2A"/>
         </a:solidFill>
+        <a:effectLst/>
       </p:bgPr>
     </p:bg>
     <p:spTree>
@@ -2325,7 +2123,7 @@
           <a:bodyPr wrap="square" lIns="0" tIns="0" rIns="0" bIns="0" rtlCol="0" anchor="ctr"/>
           <a:lstStyle/>
           <a:p>
-            <a:pPr indent="0" marL="0">
+            <a:pPr marL="0" indent="0">
               <a:buNone/>
             </a:pPr>
             <a:r>
@@ -2367,6 +2165,13 @@
             <a:prstDash val="solid"/>
           </a:ln>
         </p:spPr>
+        <p:txBody>
+          <a:bodyPr/>
+          <a:lstStyle/>
+          <a:p>
+            <a:endParaRPr lang="en-US"/>
+          </a:p>
+        </p:txBody>
       </p:sp>
       <p:sp>
         <p:nvSpPr>
@@ -2392,6 +2197,13 @@
             <a:prstDash val="solid"/>
           </a:ln>
         </p:spPr>
+        <p:txBody>
+          <a:bodyPr/>
+          <a:lstStyle/>
+          <a:p>
+            <a:endParaRPr lang="en-US"/>
+          </a:p>
+        </p:txBody>
       </p:sp>
       <p:sp>
         <p:nvSpPr>
@@ -2417,6 +2229,13 @@
             <a:prstDash val="solid"/>
           </a:ln>
         </p:spPr>
+        <p:txBody>
+          <a:bodyPr/>
+          <a:lstStyle/>
+          <a:p>
+            <a:endParaRPr lang="en-US"/>
+          </a:p>
+        </p:txBody>
       </p:sp>
       <p:sp>
         <p:nvSpPr>
@@ -2439,7 +2258,7 @@
           <a:bodyPr wrap="square" lIns="0" tIns="0" rIns="0" bIns="0" rtlCol="0" anchor="ctr"/>
           <a:lstStyle/>
           <a:p>
-            <a:pPr algn="ctr" indent="0" marL="0">
+            <a:pPr marL="0" indent="0" algn="ctr">
               <a:buNone/>
             </a:pPr>
             <a:r>
@@ -2475,7 +2294,7 @@
           <a:bodyPr wrap="square" lIns="0" tIns="0" rIns="0" bIns="0" rtlCol="0" anchor="ctr"/>
           <a:lstStyle/>
           <a:p>
-            <a:pPr indent="0" marL="0">
+            <a:pPr marL="0" indent="0">
               <a:buNone/>
             </a:pPr>
             <a:r>
@@ -2514,7 +2333,7 @@
           <a:bodyPr wrap="square" lIns="0" tIns="0" rIns="0" bIns="0" rtlCol="0" anchor="t"/>
           <a:lstStyle/>
           <a:p>
-            <a:pPr indent="0" marL="0">
+            <a:pPr marL="0" indent="0">
               <a:buNone/>
             </a:pPr>
             <a:r>
@@ -2553,7 +2372,7 @@
           <a:bodyPr wrap="square" lIns="0" tIns="0" rIns="0" bIns="0" rtlCol="0" anchor="ctr"/>
           <a:lstStyle/>
           <a:p>
-            <a:pPr algn="ctr" indent="0" marL="0">
+            <a:pPr marL="0" indent="0" algn="ctr">
               <a:buNone/>
             </a:pPr>
             <a:r>
@@ -2592,6 +2411,13 @@
             <a:prstDash val="solid"/>
           </a:ln>
         </p:spPr>
+        <p:txBody>
+          <a:bodyPr/>
+          <a:lstStyle/>
+          <a:p>
+            <a:endParaRPr lang="en-US"/>
+          </a:p>
+        </p:txBody>
       </p:sp>
       <p:sp>
         <p:nvSpPr>
@@ -2617,6 +2443,13 @@
             <a:prstDash val="solid"/>
           </a:ln>
         </p:spPr>
+        <p:txBody>
+          <a:bodyPr/>
+          <a:lstStyle/>
+          <a:p>
+            <a:endParaRPr lang="en-US"/>
+          </a:p>
+        </p:txBody>
       </p:sp>
       <p:sp>
         <p:nvSpPr>
@@ -2639,7 +2472,7 @@
           <a:bodyPr wrap="square" lIns="0" tIns="0" rIns="0" bIns="0" rtlCol="0" anchor="ctr"/>
           <a:lstStyle/>
           <a:p>
-            <a:pPr algn="ctr" indent="0" marL="0">
+            <a:pPr marL="0" indent="0" algn="ctr">
               <a:buNone/>
             </a:pPr>
             <a:r>
@@ -2675,7 +2508,7 @@
           <a:bodyPr wrap="square" lIns="0" tIns="0" rIns="0" bIns="0" rtlCol="0" anchor="ctr"/>
           <a:lstStyle/>
           <a:p>
-            <a:pPr indent="0" marL="0">
+            <a:pPr marL="0" indent="0">
               <a:buNone/>
             </a:pPr>
             <a:r>
@@ -2714,7 +2547,7 @@
           <a:bodyPr wrap="square" lIns="0" tIns="0" rIns="0" bIns="0" rtlCol="0" anchor="t"/>
           <a:lstStyle/>
           <a:p>
-            <a:pPr indent="0" marL="0">
+            <a:pPr marL="0" indent="0">
               <a:buNone/>
             </a:pPr>
             <a:r>
@@ -2753,7 +2586,7 @@
           <a:bodyPr wrap="square" lIns="0" tIns="0" rIns="0" bIns="0" rtlCol="0" anchor="ctr"/>
           <a:lstStyle/>
           <a:p>
-            <a:pPr algn="ctr" indent="0" marL="0">
+            <a:pPr marL="0" indent="0" algn="ctr">
               <a:buNone/>
             </a:pPr>
             <a:r>
@@ -2792,6 +2625,13 @@
             <a:prstDash val="solid"/>
           </a:ln>
         </p:spPr>
+        <p:txBody>
+          <a:bodyPr/>
+          <a:lstStyle/>
+          <a:p>
+            <a:endParaRPr lang="en-US"/>
+          </a:p>
+        </p:txBody>
       </p:sp>
       <p:sp>
         <p:nvSpPr>
@@ -2817,6 +2657,13 @@
             <a:prstDash val="solid"/>
           </a:ln>
         </p:spPr>
+        <p:txBody>
+          <a:bodyPr/>
+          <a:lstStyle/>
+          <a:p>
+            <a:endParaRPr lang="en-US"/>
+          </a:p>
+        </p:txBody>
       </p:sp>
       <p:sp>
         <p:nvSpPr>
@@ -2839,7 +2686,7 @@
           <a:bodyPr wrap="square" lIns="0" tIns="0" rIns="0" bIns="0" rtlCol="0" anchor="ctr"/>
           <a:lstStyle/>
           <a:p>
-            <a:pPr algn="ctr" indent="0" marL="0">
+            <a:pPr marL="0" indent="0" algn="ctr">
               <a:buNone/>
             </a:pPr>
             <a:r>
@@ -2875,7 +2722,7 @@
           <a:bodyPr wrap="square" lIns="0" tIns="0" rIns="0" bIns="0" rtlCol="0" anchor="ctr"/>
           <a:lstStyle/>
           <a:p>
-            <a:pPr indent="0" marL="0">
+            <a:pPr marL="0" indent="0">
               <a:buNone/>
             </a:pPr>
             <a:r>
@@ -2914,7 +2761,7 @@
           <a:bodyPr wrap="square" lIns="0" tIns="0" rIns="0" bIns="0" rtlCol="0" anchor="t"/>
           <a:lstStyle/>
           <a:p>
-            <a:pPr indent="0" marL="0">
+            <a:pPr marL="0" indent="0">
               <a:buNone/>
             </a:pPr>
             <a:r>
@@ -2948,6 +2795,7 @@
         <a:solidFill>
           <a:srgbClr val="E8F1F8"/>
         </a:solidFill>
+        <a:effectLst/>
       </p:bgPr>
     </p:bg>
     <p:spTree>
@@ -2985,7 +2833,7 @@
           <a:bodyPr wrap="square" lIns="0" tIns="0" rIns="0" bIns="0" rtlCol="0" anchor="ctr"/>
           <a:lstStyle/>
           <a:p>
-            <a:pPr indent="0" marL="0">
+            <a:pPr marL="0" indent="0">
               <a:buNone/>
             </a:pPr>
             <a:r>
@@ -3027,6 +2875,13 @@
             <a:prstDash val="solid"/>
           </a:ln>
         </p:spPr>
+        <p:txBody>
+          <a:bodyPr/>
+          <a:lstStyle/>
+          <a:p>
+            <a:endParaRPr lang="en-US"/>
+          </a:p>
+        </p:txBody>
       </p:sp>
       <p:sp>
         <p:nvSpPr>
@@ -3052,13 +2907,20 @@
             <a:prstDash val="solid"/>
           </a:ln>
           <a:effectLst>
-            <a:outerShdw sx="100000" sy="100000" kx="0" ky="0" algn="bl" rotWithShape="0" blurRad="101600" dist="25400" dir="8100000">
+            <a:outerShdw blurRad="101600" dist="25400" dir="8100000" algn="bl" rotWithShape="0">
               <a:srgbClr val="000000">
                 <a:alpha val="10000"/>
               </a:srgbClr>
             </a:outerShdw>
           </a:effectLst>
         </p:spPr>
+        <p:txBody>
+          <a:bodyPr/>
+          <a:lstStyle/>
+          <a:p>
+            <a:endParaRPr lang="en-US"/>
+          </a:p>
+        </p:txBody>
       </p:sp>
       <p:sp>
         <p:nvSpPr>
@@ -3084,6 +2946,13 @@
             <a:prstDash val="solid"/>
           </a:ln>
         </p:spPr>
+        <p:txBody>
+          <a:bodyPr/>
+          <a:lstStyle/>
+          <a:p>
+            <a:endParaRPr lang="en-US"/>
+          </a:p>
+        </p:txBody>
       </p:sp>
       <p:sp>
         <p:nvSpPr>
@@ -3106,7 +2975,7 @@
           <a:bodyPr wrap="square" lIns="0" tIns="0" rIns="0" bIns="0" rtlCol="0" anchor="ctr"/>
           <a:lstStyle/>
           <a:p>
-            <a:pPr indent="0" marL="0">
+            <a:pPr marL="0" indent="0">
               <a:buNone/>
             </a:pPr>
             <a:r>
@@ -3145,7 +3014,7 @@
           <a:bodyPr wrap="square" lIns="0" tIns="0" rIns="0" bIns="0" rtlCol="0" anchor="t"/>
           <a:lstStyle/>
           <a:p>
-            <a:pPr indent="0" marL="0">
+            <a:pPr marL="0" indent="0">
               <a:buNone/>
             </a:pPr>
             <a:r>
@@ -3162,13 +3031,13 @@
             <a:endParaRPr lang="en-US" sz="1250" dirty="0"/>
           </a:p>
           <a:p>
-            <a:pPr indent="0" marL="0">
+            <a:pPr marL="0" indent="0">
               <a:buNone/>
             </a:pPr>
             <a:endParaRPr lang="en-US" sz="1250" dirty="0"/>
           </a:p>
           <a:p>
-            <a:pPr indent="0" marL="0">
+            <a:pPr marL="0" indent="0">
               <a:buNone/>
             </a:pPr>
             <a:r>
@@ -3207,7 +3076,7 @@
           <a:bodyPr wrap="square" lIns="0" tIns="0" rIns="0" bIns="0" rtlCol="0" anchor="ctr"/>
           <a:lstStyle/>
           <a:p>
-            <a:pPr indent="0" marL="0">
+            <a:pPr marL="0" indent="0">
               <a:buNone/>
             </a:pPr>
             <a:r>
@@ -3249,13 +3118,20 @@
             <a:prstDash val="solid"/>
           </a:ln>
           <a:effectLst>
-            <a:outerShdw sx="100000" sy="100000" kx="0" ky="0" algn="bl" rotWithShape="0" blurRad="101600" dist="25400" dir="8100000">
+            <a:outerShdw blurRad="101600" dist="25400" dir="8100000" algn="bl" rotWithShape="0">
               <a:srgbClr val="000000">
                 <a:alpha val="10000"/>
               </a:srgbClr>
             </a:outerShdw>
           </a:effectLst>
         </p:spPr>
+        <p:txBody>
+          <a:bodyPr/>
+          <a:lstStyle/>
+          <a:p>
+            <a:endParaRPr lang="en-US"/>
+          </a:p>
+        </p:txBody>
       </p:sp>
       <p:sp>
         <p:nvSpPr>
@@ -3281,6 +3157,13 @@
             <a:prstDash val="solid"/>
           </a:ln>
         </p:spPr>
+        <p:txBody>
+          <a:bodyPr/>
+          <a:lstStyle/>
+          <a:p>
+            <a:endParaRPr lang="en-US"/>
+          </a:p>
+        </p:txBody>
       </p:sp>
       <p:sp>
         <p:nvSpPr>
@@ -3303,7 +3186,7 @@
           <a:bodyPr wrap="square" lIns="0" tIns="0" rIns="0" bIns="0" rtlCol="0" anchor="ctr"/>
           <a:lstStyle/>
           <a:p>
-            <a:pPr indent="0" marL="0">
+            <a:pPr marL="0" indent="0">
               <a:buNone/>
             </a:pPr>
             <a:r>
@@ -3342,7 +3225,7 @@
           <a:bodyPr wrap="square" lIns="0" tIns="0" rIns="0" bIns="0" rtlCol="0" anchor="t"/>
           <a:lstStyle/>
           <a:p>
-            <a:pPr indent="0" marL="0">
+            <a:pPr marL="0" indent="0">
               <a:buNone/>
             </a:pPr>
             <a:r>
@@ -3359,13 +3242,13 @@
             <a:endParaRPr lang="en-US" sz="1250" dirty="0"/>
           </a:p>
           <a:p>
-            <a:pPr indent="0" marL="0">
+            <a:pPr marL="0" indent="0">
               <a:buNone/>
             </a:pPr>
             <a:endParaRPr lang="en-US" sz="1250" dirty="0"/>
           </a:p>
           <a:p>
-            <a:pPr indent="0" marL="0">
+            <a:pPr marL="0" indent="0">
               <a:buNone/>
             </a:pPr>
             <a:r>
@@ -3404,7 +3287,7 @@
           <a:bodyPr wrap="square" lIns="0" tIns="0" rIns="0" bIns="0" rtlCol="0" anchor="ctr"/>
           <a:lstStyle/>
           <a:p>
-            <a:pPr indent="0" marL="0">
+            <a:pPr marL="0" indent="0">
               <a:buNone/>
             </a:pPr>
             <a:r>
@@ -3438,6 +3321,7 @@
         <a:solidFill>
           <a:srgbClr val="0D1B2A"/>
         </a:solidFill>
+        <a:effectLst/>
       </p:bgPr>
     </p:bg>
     <p:spTree>
@@ -3475,11 +3359,11 @@
           <a:bodyPr wrap="square" lIns="0" tIns="0" rIns="0" bIns="0" rtlCol="0" anchor="ctr"/>
           <a:lstStyle/>
           <a:p>
-            <a:pPr indent="0" marL="0">
-              <a:buNone/>
-            </a:pPr>
-            <a:r>
-              <a:rPr lang="en-US" sz="3200" b="1" dirty="0">
+            <a:pPr marL="0" indent="0">
+              <a:buNone/>
+            </a:pPr>
+            <a:r>
+              <a:rPr lang="en-US" sz="3200" b="1">
                 <a:solidFill>
                   <a:srgbClr val="FFFFFF"/>
                 </a:solidFill>
@@ -3487,7 +3371,18 @@
                 <a:ea typeface="Georgia" pitchFamily="34" charset="-122"/>
                 <a:cs typeface="Georgia" pitchFamily="34" charset="-120"/>
               </a:rPr>
-              <a:t>Live Demo</a:t>
+              <a:t>User </a:t>
+            </a:r>
+            <a:r>
+              <a:rPr lang="en-US" sz="3200" b="1" dirty="0">
+                <a:solidFill>
+                  <a:srgbClr val="FFFFFF"/>
+                </a:solidFill>
+                <a:latin typeface="Georgia" pitchFamily="34" charset="0"/>
+                <a:ea typeface="Georgia" pitchFamily="34" charset="-122"/>
+                <a:cs typeface="Georgia" pitchFamily="34" charset="-120"/>
+              </a:rPr>
+              <a:t>Interface</a:t>
             </a:r>
             <a:endParaRPr lang="en-US" sz="3200" dirty="0"/>
           </a:p>
@@ -3517,23 +3412,172 @@
             <a:prstDash val="solid"/>
           </a:ln>
         </p:spPr>
-      </p:sp>
-      <p:sp>
-        <p:nvSpPr>
-          <p:cNvPr id="4" name="Shape 2"/>
-          <p:cNvSpPr/>
-          <p:nvPr/>
-        </p:nvSpPr>
-        <p:spPr>
-          <a:xfrm>
-            <a:off x="457200" y="1051560"/>
-            <a:ext cx="8229600" cy="3749040"/>
-          </a:xfrm>
-          <a:prstGeom prst="rect">
-            <a:avLst/>
-          </a:prstGeom>
-          <a:solidFill>
-            <a:srgbClr val="1B2D42"/>
+        <p:txBody>
+          <a:bodyPr/>
+          <a:lstStyle/>
+          <a:p>
+            <a:endParaRPr lang="en-US"/>
+          </a:p>
+        </p:txBody>
+      </p:sp>
+      <p:sp>
+        <p:nvSpPr>
+          <p:cNvPr id="5" name="Shape 3"/>
+          <p:cNvSpPr/>
+          <p:nvPr/>
+        </p:nvSpPr>
+        <p:spPr>
+          <a:xfrm>
+            <a:off x="731520" y="1234440"/>
+            <a:ext cx="3200400" cy="457200"/>
+          </a:xfrm>
+          <a:prstGeom prst="rect">
+            <a:avLst/>
+          </a:prstGeom>
+          <a:solidFill>
+            <a:srgbClr val="0D1B2A"/>
+          </a:solidFill>
+          <a:ln w="12700">
+            <a:solidFill>
+              <a:srgbClr val="4FC3F7"/>
+            </a:solidFill>
+            <a:prstDash val="solid"/>
+          </a:ln>
+        </p:spPr>
+        <p:txBody>
+          <a:bodyPr/>
+          <a:lstStyle/>
+          <a:p>
+            <a:endParaRPr lang="en-US"/>
+          </a:p>
+        </p:txBody>
+      </p:sp>
+      <p:sp>
+        <p:nvSpPr>
+          <p:cNvPr id="6" name="Text 4"/>
+          <p:cNvSpPr/>
+          <p:nvPr/>
+        </p:nvSpPr>
+        <p:spPr>
+          <a:xfrm>
+            <a:off x="822960" y="1261872"/>
+            <a:ext cx="3017520" cy="402336"/>
+          </a:xfrm>
+          <a:prstGeom prst="rect">
+            <a:avLst/>
+          </a:prstGeom>
+          <a:noFill/>
+          <a:ln/>
+        </p:spPr>
+        <p:txBody>
+          <a:bodyPr wrap="square" lIns="0" tIns="0" rIns="0" bIns="0" rtlCol="0" anchor="ctr"/>
+          <a:lstStyle/>
+          <a:p>
+            <a:pPr marL="0" indent="0">
+              <a:buNone/>
+            </a:pPr>
+            <a:r>
+              <a:rPr lang="en-US" sz="1100" dirty="0">
+                <a:solidFill>
+                  <a:srgbClr val="FFFFFF"/>
+                </a:solidFill>
+                <a:latin typeface="Calibri" pitchFamily="34" charset="0"/>
+                <a:ea typeface="Calibri" pitchFamily="34" charset="-122"/>
+                <a:cs typeface="Calibri" pitchFamily="34" charset="-120"/>
+              </a:rPr>
+              <a:t>Origin: JFK – New York, USA</a:t>
+            </a:r>
+            <a:endParaRPr lang="en-US" sz="1100" dirty="0"/>
+          </a:p>
+        </p:txBody>
+      </p:sp>
+      <p:sp>
+        <p:nvSpPr>
+          <p:cNvPr id="7" name="Shape 5"/>
+          <p:cNvSpPr/>
+          <p:nvPr/>
+        </p:nvSpPr>
+        <p:spPr>
+          <a:xfrm>
+            <a:off x="4114800" y="1234440"/>
+            <a:ext cx="3200400" cy="457200"/>
+          </a:xfrm>
+          <a:prstGeom prst="rect">
+            <a:avLst/>
+          </a:prstGeom>
+          <a:solidFill>
+            <a:srgbClr val="0D1B2A"/>
+          </a:solidFill>
+          <a:ln w="12700">
+            <a:solidFill>
+              <a:srgbClr val="4FC3F7"/>
+            </a:solidFill>
+            <a:prstDash val="solid"/>
+          </a:ln>
+        </p:spPr>
+        <p:txBody>
+          <a:bodyPr/>
+          <a:lstStyle/>
+          <a:p>
+            <a:endParaRPr lang="en-US"/>
+          </a:p>
+        </p:txBody>
+      </p:sp>
+      <p:sp>
+        <p:nvSpPr>
+          <p:cNvPr id="8" name="Text 6"/>
+          <p:cNvSpPr/>
+          <p:nvPr/>
+        </p:nvSpPr>
+        <p:spPr>
+          <a:xfrm>
+            <a:off x="4206240" y="1261872"/>
+            <a:ext cx="3017520" cy="402336"/>
+          </a:xfrm>
+          <a:prstGeom prst="rect">
+            <a:avLst/>
+          </a:prstGeom>
+          <a:noFill/>
+          <a:ln/>
+        </p:spPr>
+        <p:txBody>
+          <a:bodyPr wrap="square" lIns="0" tIns="0" rIns="0" bIns="0" rtlCol="0" anchor="ctr"/>
+          <a:lstStyle/>
+          <a:p>
+            <a:pPr marL="0" indent="0">
+              <a:buNone/>
+            </a:pPr>
+            <a:r>
+              <a:rPr lang="en-US" sz="1100" dirty="0">
+                <a:solidFill>
+                  <a:srgbClr val="FFFFFF"/>
+                </a:solidFill>
+                <a:latin typeface="Calibri" pitchFamily="34" charset="0"/>
+                <a:ea typeface="Calibri" pitchFamily="34" charset="-122"/>
+                <a:cs typeface="Calibri" pitchFamily="34" charset="-120"/>
+              </a:rPr>
+              <a:t>Destination: NRT – Tokyo, Japan</a:t>
+            </a:r>
+            <a:endParaRPr lang="en-US" sz="1100" dirty="0"/>
+          </a:p>
+        </p:txBody>
+      </p:sp>
+      <p:sp>
+        <p:nvSpPr>
+          <p:cNvPr id="9" name="Shape 7"/>
+          <p:cNvSpPr/>
+          <p:nvPr/>
+        </p:nvSpPr>
+        <p:spPr>
+          <a:xfrm>
+            <a:off x="7498080" y="1234440"/>
+            <a:ext cx="1005840" cy="457200"/>
+          </a:xfrm>
+          <a:prstGeom prst="rect">
+            <a:avLst/>
+          </a:prstGeom>
+          <a:solidFill>
+            <a:srgbClr val="1A6DAE"/>
           </a:solidFill>
           <a:ln w="12700">
             <a:solidFill>
@@ -3542,17 +3586,241 @@
             <a:prstDash val="solid"/>
           </a:ln>
         </p:spPr>
-      </p:sp>
-      <p:sp>
-        <p:nvSpPr>
-          <p:cNvPr id="5" name="Shape 3"/>
-          <p:cNvSpPr/>
-          <p:nvPr/>
-        </p:nvSpPr>
-        <p:spPr>
-          <a:xfrm>
-            <a:off x="731520" y="1234440"/>
-            <a:ext cx="3200400" cy="457200"/>
+        <p:txBody>
+          <a:bodyPr/>
+          <a:lstStyle/>
+          <a:p>
+            <a:endParaRPr lang="en-US"/>
+          </a:p>
+        </p:txBody>
+      </p:sp>
+      <p:sp>
+        <p:nvSpPr>
+          <p:cNvPr id="10" name="Text 8"/>
+          <p:cNvSpPr/>
+          <p:nvPr/>
+        </p:nvSpPr>
+        <p:spPr>
+          <a:xfrm>
+            <a:off x="7498080" y="1261872"/>
+            <a:ext cx="1005840" cy="402336"/>
+          </a:xfrm>
+          <a:prstGeom prst="rect">
+            <a:avLst/>
+          </a:prstGeom>
+          <a:noFill/>
+          <a:ln/>
+        </p:spPr>
+        <p:txBody>
+          <a:bodyPr wrap="square" lIns="0" tIns="0" rIns="0" bIns="0" rtlCol="0" anchor="ctr"/>
+          <a:lstStyle/>
+          <a:p>
+            <a:pPr marL="0" indent="0" algn="ctr">
+              <a:buNone/>
+            </a:pPr>
+            <a:r>
+              <a:rPr lang="en-US" sz="1100" b="1" dirty="0">
+                <a:solidFill>
+                  <a:srgbClr val="FFFFFF"/>
+                </a:solidFill>
+              </a:rPr>
+              <a:t>Search</a:t>
+            </a:r>
+            <a:endParaRPr lang="en-US" sz="1100" dirty="0"/>
+          </a:p>
+        </p:txBody>
+      </p:sp>
+      <p:sp>
+        <p:nvSpPr>
+          <p:cNvPr id="11" name="Shape 9"/>
+          <p:cNvSpPr/>
+          <p:nvPr/>
+        </p:nvSpPr>
+        <p:spPr>
+          <a:xfrm>
+            <a:off x="731520" y="1874520"/>
+            <a:ext cx="3657600" cy="2651760"/>
+          </a:xfrm>
+          <a:prstGeom prst="rect">
+            <a:avLst/>
+          </a:prstGeom>
+          <a:solidFill>
+            <a:srgbClr val="0D1B2A"/>
+          </a:solidFill>
+          <a:ln w="12700">
+            <a:solidFill>
+              <a:srgbClr val="F4A620"/>
+            </a:solidFill>
+            <a:prstDash val="solid"/>
+          </a:ln>
+        </p:spPr>
+        <p:txBody>
+          <a:bodyPr/>
+          <a:lstStyle/>
+          <a:p>
+            <a:endParaRPr lang="en-US"/>
+          </a:p>
+        </p:txBody>
+      </p:sp>
+      <p:sp>
+        <p:nvSpPr>
+          <p:cNvPr id="12" name="Shape 10"/>
+          <p:cNvSpPr/>
+          <p:nvPr/>
+        </p:nvSpPr>
+        <p:spPr>
+          <a:xfrm>
+            <a:off x="731520" y="1874520"/>
+            <a:ext cx="3657600" cy="365760"/>
+          </a:xfrm>
+          <a:prstGeom prst="rect">
+            <a:avLst/>
+          </a:prstGeom>
+          <a:solidFill>
+            <a:srgbClr val="F4A620"/>
+          </a:solidFill>
+          <a:ln w="12700">
+            <a:solidFill>
+              <a:srgbClr val="F4A620"/>
+            </a:solidFill>
+            <a:prstDash val="solid"/>
+          </a:ln>
+        </p:spPr>
+        <p:txBody>
+          <a:bodyPr/>
+          <a:lstStyle/>
+          <a:p>
+            <a:endParaRPr lang="en-US"/>
+          </a:p>
+        </p:txBody>
+      </p:sp>
+      <p:sp>
+        <p:nvSpPr>
+          <p:cNvPr id="13" name="Text 11"/>
+          <p:cNvSpPr/>
+          <p:nvPr/>
+        </p:nvSpPr>
+        <p:spPr>
+          <a:xfrm>
+            <a:off x="822960" y="1892808"/>
+            <a:ext cx="3474720" cy="329184"/>
+          </a:xfrm>
+          <a:prstGeom prst="rect">
+            <a:avLst/>
+          </a:prstGeom>
+          <a:noFill/>
+          <a:ln/>
+        </p:spPr>
+        <p:txBody>
+          <a:bodyPr wrap="square" lIns="0" tIns="0" rIns="0" bIns="0" rtlCol="0" anchor="ctr"/>
+          <a:lstStyle/>
+          <a:p>
+            <a:pPr marL="0" indent="0">
+              <a:buNone/>
+            </a:pPr>
+            <a:r>
+              <a:rPr lang="en-US" sz="1200" b="1" dirty="0">
+                <a:solidFill>
+                  <a:srgbClr val="0D1B2A"/>
+                </a:solidFill>
+                <a:latin typeface="Calibri" pitchFamily="34" charset="0"/>
+                <a:ea typeface="Calibri" pitchFamily="34" charset="-122"/>
+                <a:cs typeface="Calibri" pitchFamily="34" charset="-120"/>
+              </a:rPr>
+              <a:t>Dijkstra (Min Distance)</a:t>
+            </a:r>
+            <a:endParaRPr lang="en-US" sz="1200" dirty="0"/>
+          </a:p>
+        </p:txBody>
+      </p:sp>
+      <p:sp>
+        <p:nvSpPr>
+          <p:cNvPr id="14" name="Text 12"/>
+          <p:cNvSpPr/>
+          <p:nvPr/>
+        </p:nvSpPr>
+        <p:spPr>
+          <a:xfrm>
+            <a:off x="868680" y="2377440"/>
+            <a:ext cx="3383280" cy="731520"/>
+          </a:xfrm>
+          <a:prstGeom prst="rect">
+            <a:avLst/>
+          </a:prstGeom>
+          <a:noFill/>
+          <a:ln/>
+        </p:spPr>
+        <p:txBody>
+          <a:bodyPr wrap="square" lIns="0" tIns="0" rIns="0" bIns="0" rtlCol="0" anchor="ctr"/>
+          <a:lstStyle/>
+          <a:p>
+            <a:pPr marL="0" indent="0">
+              <a:buNone/>
+            </a:pPr>
+            <a:r>
+              <a:rPr lang="en-US" sz="1200" dirty="0">
+                <a:solidFill>
+                  <a:srgbClr val="FFFFFF"/>
+                </a:solidFill>
+                <a:latin typeface="Calibri" pitchFamily="34" charset="0"/>
+                <a:ea typeface="Calibri" pitchFamily="34" charset="-122"/>
+                <a:cs typeface="Calibri" pitchFamily="34" charset="-120"/>
+              </a:rPr>
+              <a:t>JFK → ORD → ANC → NRT</a:t>
+            </a:r>
+            <a:endParaRPr lang="en-US" sz="1200" dirty="0"/>
+          </a:p>
+        </p:txBody>
+      </p:sp>
+      <p:sp>
+        <p:nvSpPr>
+          <p:cNvPr id="15" name="Text 13"/>
+          <p:cNvSpPr/>
+          <p:nvPr/>
+        </p:nvSpPr>
+        <p:spPr>
+          <a:xfrm>
+            <a:off x="868680" y="3200400"/>
+            <a:ext cx="3383280" cy="320040"/>
+          </a:xfrm>
+          <a:prstGeom prst="rect">
+            <a:avLst/>
+          </a:prstGeom>
+          <a:noFill/>
+          <a:ln/>
+        </p:spPr>
+        <p:txBody>
+          <a:bodyPr wrap="square" lIns="0" tIns="0" rIns="0" bIns="0" rtlCol="0" anchor="ctr"/>
+          <a:lstStyle/>
+          <a:p>
+            <a:pPr marL="0" indent="0">
+              <a:buNone/>
+            </a:pPr>
+            <a:r>
+              <a:rPr lang="en-US" sz="1100" i="1" dirty="0">
+                <a:solidFill>
+                  <a:srgbClr val="F4A620"/>
+                </a:solidFill>
+                <a:latin typeface="Calibri" pitchFamily="34" charset="0"/>
+                <a:ea typeface="Calibri" pitchFamily="34" charset="-122"/>
+                <a:cs typeface="Calibri" pitchFamily="34" charset="-120"/>
+              </a:rPr>
+              <a:t>10,838 km  |  2 stops</a:t>
+            </a:r>
+            <a:endParaRPr lang="en-US" sz="1100" dirty="0"/>
+          </a:p>
+        </p:txBody>
+      </p:sp>
+      <p:sp>
+        <p:nvSpPr>
+          <p:cNvPr id="16" name="Shape 14"/>
+          <p:cNvSpPr/>
+          <p:nvPr/>
+        </p:nvSpPr>
+        <p:spPr>
+          <a:xfrm>
+            <a:off x="4663440" y="1874520"/>
+            <a:ext cx="3657600" cy="2651760"/>
           </a:xfrm>
           <a:prstGeom prst="rect">
             <a:avLst/>
@@ -3567,62 +3835,30 @@
             <a:prstDash val="solid"/>
           </a:ln>
         </p:spPr>
-      </p:sp>
-      <p:sp>
-        <p:nvSpPr>
-          <p:cNvPr id="6" name="Text 4"/>
-          <p:cNvSpPr/>
-          <p:nvPr/>
-        </p:nvSpPr>
-        <p:spPr>
-          <a:xfrm>
-            <a:off x="822960" y="1261872"/>
-            <a:ext cx="3017520" cy="402336"/>
-          </a:xfrm>
-          <a:prstGeom prst="rect">
-            <a:avLst/>
-          </a:prstGeom>
-          <a:noFill/>
-          <a:ln/>
-        </p:spPr>
-        <p:txBody>
-          <a:bodyPr wrap="square" lIns="0" tIns="0" rIns="0" bIns="0" rtlCol="0" anchor="ctr"/>
-          <a:lstStyle/>
-          <a:p>
-            <a:pPr indent="0" marL="0">
-              <a:buNone/>
-            </a:pPr>
-            <a:r>
-              <a:rPr lang="en-US" sz="1100" dirty="0">
-                <a:solidFill>
-                  <a:srgbClr val="FFFFFF"/>
-                </a:solidFill>
-                <a:latin typeface="Calibri" pitchFamily="34" charset="0"/>
-                <a:ea typeface="Calibri" pitchFamily="34" charset="-122"/>
-                <a:cs typeface="Calibri" pitchFamily="34" charset="-120"/>
-              </a:rPr>
-              <a:t>Origin: JFK – New York, USA</a:t>
-            </a:r>
-            <a:endParaRPr lang="en-US" sz="1100" dirty="0"/>
-          </a:p>
-        </p:txBody>
-      </p:sp>
-      <p:sp>
-        <p:nvSpPr>
-          <p:cNvPr id="7" name="Shape 5"/>
-          <p:cNvSpPr/>
-          <p:nvPr/>
-        </p:nvSpPr>
-        <p:spPr>
-          <a:xfrm>
-            <a:off x="4114800" y="1234440"/>
-            <a:ext cx="3200400" cy="457200"/>
-          </a:xfrm>
-          <a:prstGeom prst="rect">
-            <a:avLst/>
-          </a:prstGeom>
-          <a:solidFill>
-            <a:srgbClr val="0D1B2A"/>
+        <p:txBody>
+          <a:bodyPr/>
+          <a:lstStyle/>
+          <a:p>
+            <a:endParaRPr lang="en-US"/>
+          </a:p>
+        </p:txBody>
+      </p:sp>
+      <p:sp>
+        <p:nvSpPr>
+          <p:cNvPr id="17" name="Shape 15"/>
+          <p:cNvSpPr/>
+          <p:nvPr/>
+        </p:nvSpPr>
+        <p:spPr>
+          <a:xfrm>
+            <a:off x="4663440" y="1874520"/>
+            <a:ext cx="3657600" cy="365760"/>
+          </a:xfrm>
+          <a:prstGeom prst="rect">
+            <a:avLst/>
+          </a:prstGeom>
+          <a:solidFill>
+            <a:srgbClr val="4FC3F7"/>
           </a:solidFill>
           <a:ln w="12700">
             <a:solidFill>
@@ -3631,191 +3867,87 @@
             <a:prstDash val="solid"/>
           </a:ln>
         </p:spPr>
-      </p:sp>
-      <p:sp>
-        <p:nvSpPr>
-          <p:cNvPr id="8" name="Text 6"/>
-          <p:cNvSpPr/>
-          <p:nvPr/>
-        </p:nvSpPr>
-        <p:spPr>
-          <a:xfrm>
-            <a:off x="4206240" y="1261872"/>
-            <a:ext cx="3017520" cy="402336"/>
-          </a:xfrm>
-          <a:prstGeom prst="rect">
-            <a:avLst/>
-          </a:prstGeom>
-          <a:noFill/>
-          <a:ln/>
-        </p:spPr>
-        <p:txBody>
-          <a:bodyPr wrap="square" lIns="0" tIns="0" rIns="0" bIns="0" rtlCol="0" anchor="ctr"/>
-          <a:lstStyle/>
-          <a:p>
-            <a:pPr indent="0" marL="0">
-              <a:buNone/>
-            </a:pPr>
-            <a:r>
-              <a:rPr lang="en-US" sz="1100" dirty="0">
-                <a:solidFill>
-                  <a:srgbClr val="FFFFFF"/>
+        <p:txBody>
+          <a:bodyPr/>
+          <a:lstStyle/>
+          <a:p>
+            <a:endParaRPr lang="en-US"/>
+          </a:p>
+        </p:txBody>
+      </p:sp>
+      <p:sp>
+        <p:nvSpPr>
+          <p:cNvPr id="18" name="Text 16"/>
+          <p:cNvSpPr/>
+          <p:nvPr/>
+        </p:nvSpPr>
+        <p:spPr>
+          <a:xfrm>
+            <a:off x="4754880" y="1892808"/>
+            <a:ext cx="3474720" cy="329184"/>
+          </a:xfrm>
+          <a:prstGeom prst="rect">
+            <a:avLst/>
+          </a:prstGeom>
+          <a:noFill/>
+          <a:ln/>
+        </p:spPr>
+        <p:txBody>
+          <a:bodyPr wrap="square" lIns="0" tIns="0" rIns="0" bIns="0" rtlCol="0" anchor="ctr"/>
+          <a:lstStyle/>
+          <a:p>
+            <a:pPr marL="0" indent="0">
+              <a:buNone/>
+            </a:pPr>
+            <a:r>
+              <a:rPr lang="en-US" sz="1200" b="1" dirty="0">
+                <a:solidFill>
+                  <a:srgbClr val="0D1B2A"/>
                 </a:solidFill>
                 <a:latin typeface="Calibri" pitchFamily="34" charset="0"/>
                 <a:ea typeface="Calibri" pitchFamily="34" charset="-122"/>
                 <a:cs typeface="Calibri" pitchFamily="34" charset="-120"/>
               </a:rPr>
-              <a:t>Destination: NRT – Tokyo, Japan</a:t>
-            </a:r>
-            <a:endParaRPr lang="en-US" sz="1100" dirty="0"/>
-          </a:p>
-        </p:txBody>
-      </p:sp>
-      <p:sp>
-        <p:nvSpPr>
-          <p:cNvPr id="9" name="Shape 7"/>
-          <p:cNvSpPr/>
-          <p:nvPr/>
-        </p:nvSpPr>
-        <p:spPr>
-          <a:xfrm>
-            <a:off x="7498080" y="1234440"/>
-            <a:ext cx="1005840" cy="457200"/>
-          </a:xfrm>
-          <a:prstGeom prst="rect">
-            <a:avLst/>
-          </a:prstGeom>
-          <a:solidFill>
-            <a:srgbClr val="1A6DAE"/>
-          </a:solidFill>
-          <a:ln w="12700">
-            <a:solidFill>
-              <a:srgbClr val="1A6DAE"/>
-            </a:solidFill>
-            <a:prstDash val="solid"/>
-          </a:ln>
-        </p:spPr>
-      </p:sp>
-      <p:sp>
-        <p:nvSpPr>
-          <p:cNvPr id="10" name="Text 8"/>
-          <p:cNvSpPr/>
-          <p:nvPr/>
-        </p:nvSpPr>
-        <p:spPr>
-          <a:xfrm>
-            <a:off x="7498080" y="1261872"/>
-            <a:ext cx="1005840" cy="402336"/>
-          </a:xfrm>
-          <a:prstGeom prst="rect">
-            <a:avLst/>
-          </a:prstGeom>
-          <a:noFill/>
-          <a:ln/>
-        </p:spPr>
-        <p:txBody>
-          <a:bodyPr wrap="square" lIns="0" tIns="0" rIns="0" bIns="0" rtlCol="0" anchor="ctr"/>
-          <a:lstStyle/>
-          <a:p>
-            <a:pPr algn="ctr" indent="0" marL="0">
-              <a:buNone/>
-            </a:pPr>
-            <a:r>
-              <a:rPr lang="en-US" sz="1100" b="1" dirty="0">
+              <a:t>BFS (Fewest Stops)</a:t>
+            </a:r>
+            <a:endParaRPr lang="en-US" sz="1200" dirty="0"/>
+          </a:p>
+        </p:txBody>
+      </p:sp>
+      <p:sp>
+        <p:nvSpPr>
+          <p:cNvPr id="19" name="Text 17"/>
+          <p:cNvSpPr/>
+          <p:nvPr/>
+        </p:nvSpPr>
+        <p:spPr>
+          <a:xfrm>
+            <a:off x="4800600" y="2377440"/>
+            <a:ext cx="3383280" cy="731520"/>
+          </a:xfrm>
+          <a:prstGeom prst="rect">
+            <a:avLst/>
+          </a:prstGeom>
+          <a:noFill/>
+          <a:ln/>
+        </p:spPr>
+        <p:txBody>
+          <a:bodyPr wrap="square" lIns="0" tIns="0" rIns="0" bIns="0" rtlCol="0" anchor="ctr"/>
+          <a:lstStyle/>
+          <a:p>
+            <a:pPr marL="0" indent="0">
+              <a:buNone/>
+            </a:pPr>
+            <a:r>
+              <a:rPr lang="en-US" sz="1200" dirty="0">
                 <a:solidFill>
                   <a:srgbClr val="FFFFFF"/>
-                </a:solidFill>
-              </a:rPr>
-              <a:t>Search</a:t>
-            </a:r>
-            <a:endParaRPr lang="en-US" sz="1100" dirty="0"/>
-          </a:p>
-        </p:txBody>
-      </p:sp>
-      <p:sp>
-        <p:nvSpPr>
-          <p:cNvPr id="11" name="Shape 9"/>
-          <p:cNvSpPr/>
-          <p:nvPr/>
-        </p:nvSpPr>
-        <p:spPr>
-          <a:xfrm>
-            <a:off x="731520" y="1874520"/>
-            <a:ext cx="3657600" cy="2651760"/>
-          </a:xfrm>
-          <a:prstGeom prst="rect">
-            <a:avLst/>
-          </a:prstGeom>
-          <a:solidFill>
-            <a:srgbClr val="0D1B2A"/>
-          </a:solidFill>
-          <a:ln w="12700">
-            <a:solidFill>
-              <a:srgbClr val="F4A620"/>
-            </a:solidFill>
-            <a:prstDash val="solid"/>
-          </a:ln>
-        </p:spPr>
-      </p:sp>
-      <p:sp>
-        <p:nvSpPr>
-          <p:cNvPr id="12" name="Shape 10"/>
-          <p:cNvSpPr/>
-          <p:nvPr/>
-        </p:nvSpPr>
-        <p:spPr>
-          <a:xfrm>
-            <a:off x="731520" y="1874520"/>
-            <a:ext cx="3657600" cy="365760"/>
-          </a:xfrm>
-          <a:prstGeom prst="rect">
-            <a:avLst/>
-          </a:prstGeom>
-          <a:solidFill>
-            <a:srgbClr val="F4A620"/>
-          </a:solidFill>
-          <a:ln w="12700">
-            <a:solidFill>
-              <a:srgbClr val="F4A620"/>
-            </a:solidFill>
-            <a:prstDash val="solid"/>
-          </a:ln>
-        </p:spPr>
-      </p:sp>
-      <p:sp>
-        <p:nvSpPr>
-          <p:cNvPr id="13" name="Text 11"/>
-          <p:cNvSpPr/>
-          <p:nvPr/>
-        </p:nvSpPr>
-        <p:spPr>
-          <a:xfrm>
-            <a:off x="822960" y="1892808"/>
-            <a:ext cx="3474720" cy="329184"/>
-          </a:xfrm>
-          <a:prstGeom prst="rect">
-            <a:avLst/>
-          </a:prstGeom>
-          <a:noFill/>
-          <a:ln/>
-        </p:spPr>
-        <p:txBody>
-          <a:bodyPr wrap="square" lIns="0" tIns="0" rIns="0" bIns="0" rtlCol="0" anchor="ctr"/>
-          <a:lstStyle/>
-          <a:p>
-            <a:pPr indent="0" marL="0">
-              <a:buNone/>
-            </a:pPr>
-            <a:r>
-              <a:rPr lang="en-US" sz="1200" b="1" dirty="0">
-                <a:solidFill>
-                  <a:srgbClr val="0D1B2A"/>
                 </a:solidFill>
                 <a:latin typeface="Calibri" pitchFamily="34" charset="0"/>
                 <a:ea typeface="Calibri" pitchFamily="34" charset="-122"/>
                 <a:cs typeface="Calibri" pitchFamily="34" charset="-120"/>
               </a:rPr>
-              <a:t>Dijkstra (Min Distance)</a:t>
+              <a:t>JFK → NRT</a:t>
             </a:r>
             <a:endParaRPr lang="en-US" sz="1200" dirty="0"/>
           </a:p>
@@ -3823,288 +3955,113 @@
       </p:sp>
       <p:sp>
         <p:nvSpPr>
-          <p:cNvPr id="14" name="Text 12"/>
-          <p:cNvSpPr/>
-          <p:nvPr/>
-        </p:nvSpPr>
-        <p:spPr>
-          <a:xfrm>
-            <a:off x="868680" y="2377440"/>
-            <a:ext cx="3383280" cy="731520"/>
-          </a:xfrm>
-          <a:prstGeom prst="rect">
-            <a:avLst/>
-          </a:prstGeom>
-          <a:noFill/>
-          <a:ln/>
-        </p:spPr>
-        <p:txBody>
-          <a:bodyPr wrap="square" lIns="0" tIns="0" rIns="0" bIns="0" rtlCol="0" anchor="ctr"/>
-          <a:lstStyle/>
-          <a:p>
-            <a:pPr indent="0" marL="0">
-              <a:buNone/>
-            </a:pPr>
-            <a:r>
-              <a:rPr lang="en-US" sz="1200" dirty="0">
-                <a:solidFill>
-                  <a:srgbClr val="FFFFFF"/>
+          <p:cNvPr id="20" name="Text 18"/>
+          <p:cNvSpPr/>
+          <p:nvPr/>
+        </p:nvSpPr>
+        <p:spPr>
+          <a:xfrm>
+            <a:off x="4800600" y="3200400"/>
+            <a:ext cx="3383280" cy="320040"/>
+          </a:xfrm>
+          <a:prstGeom prst="rect">
+            <a:avLst/>
+          </a:prstGeom>
+          <a:noFill/>
+          <a:ln/>
+        </p:spPr>
+        <p:txBody>
+          <a:bodyPr wrap="square" lIns="0" tIns="0" rIns="0" bIns="0" rtlCol="0" anchor="ctr"/>
+          <a:lstStyle/>
+          <a:p>
+            <a:pPr marL="0" indent="0">
+              <a:buNone/>
+            </a:pPr>
+            <a:r>
+              <a:rPr lang="en-US" sz="1100" i="1" dirty="0">
+                <a:solidFill>
+                  <a:srgbClr val="4FC3F7"/>
                 </a:solidFill>
                 <a:latin typeface="Calibri" pitchFamily="34" charset="0"/>
                 <a:ea typeface="Calibri" pitchFamily="34" charset="-122"/>
                 <a:cs typeface="Calibri" pitchFamily="34" charset="-120"/>
               </a:rPr>
-              <a:t>JFK → ORD → ANC → NRT</a:t>
-            </a:r>
-            <a:endParaRPr lang="en-US" sz="1200" dirty="0"/>
-          </a:p>
-        </p:txBody>
-      </p:sp>
-      <p:sp>
-        <p:nvSpPr>
-          <p:cNvPr id="15" name="Text 13"/>
-          <p:cNvSpPr/>
-          <p:nvPr/>
-        </p:nvSpPr>
-        <p:spPr>
-          <a:xfrm>
-            <a:off x="868680" y="3200400"/>
-            <a:ext cx="3383280" cy="320040"/>
-          </a:xfrm>
-          <a:prstGeom prst="rect">
-            <a:avLst/>
-          </a:prstGeom>
-          <a:noFill/>
-          <a:ln/>
-        </p:spPr>
-        <p:txBody>
-          <a:bodyPr wrap="square" lIns="0" tIns="0" rIns="0" bIns="0" rtlCol="0" anchor="ctr"/>
-          <a:lstStyle/>
-          <a:p>
-            <a:pPr indent="0" marL="0">
-              <a:buNone/>
-            </a:pPr>
-            <a:r>
-              <a:rPr lang="en-US" sz="1100" i="1" dirty="0">
-                <a:solidFill>
-                  <a:srgbClr val="F4A620"/>
+              <a:t>10,838 km  |  direct</a:t>
+            </a:r>
+            <a:endParaRPr lang="en-US" sz="1100" dirty="0"/>
+          </a:p>
+        </p:txBody>
+      </p:sp>
+      <p:sp>
+        <p:nvSpPr>
+          <p:cNvPr id="21" name="Text 19"/>
+          <p:cNvSpPr/>
+          <p:nvPr/>
+        </p:nvSpPr>
+        <p:spPr>
+          <a:xfrm>
+            <a:off x="731520" y="4617720"/>
+            <a:ext cx="7772400" cy="320040"/>
+          </a:xfrm>
+          <a:prstGeom prst="rect">
+            <a:avLst/>
+          </a:prstGeom>
+          <a:noFill/>
+          <a:ln/>
+        </p:spPr>
+        <p:txBody>
+          <a:bodyPr wrap="square" lIns="0" tIns="0" rIns="0" bIns="0" rtlCol="0" anchor="ctr"/>
+          <a:lstStyle/>
+          <a:p>
+            <a:pPr marL="0" indent="0">
+              <a:buNone/>
+            </a:pPr>
+            <a:r>
+              <a:rPr lang="en-US" sz="1050" dirty="0">
+                <a:solidFill>
+                  <a:srgbClr val="8FA8C0"/>
                 </a:solidFill>
                 <a:latin typeface="Calibri" pitchFamily="34" charset="0"/>
                 <a:ea typeface="Calibri" pitchFamily="34" charset="-122"/>
                 <a:cs typeface="Calibri" pitchFamily="34" charset="-120"/>
               </a:rPr>
-              <a:t>10,838 km  |  2 stops</a:t>
-            </a:r>
-            <a:endParaRPr lang="en-US" sz="1100" dirty="0"/>
-          </a:p>
-        </p:txBody>
-      </p:sp>
-      <p:sp>
-        <p:nvSpPr>
-          <p:cNvPr id="16" name="Shape 14"/>
-          <p:cNvSpPr/>
-          <p:nvPr/>
-        </p:nvSpPr>
-        <p:spPr>
-          <a:xfrm>
-            <a:off x="4663440" y="1874520"/>
-            <a:ext cx="3657600" cy="2651760"/>
-          </a:xfrm>
-          <a:prstGeom prst="rect">
-            <a:avLst/>
-          </a:prstGeom>
-          <a:solidFill>
-            <a:srgbClr val="0D1B2A"/>
-          </a:solidFill>
-          <a:ln w="12700">
-            <a:solidFill>
-              <a:srgbClr val="4FC3F7"/>
-            </a:solidFill>
-            <a:prstDash val="solid"/>
-          </a:ln>
-        </p:spPr>
-      </p:sp>
-      <p:sp>
-        <p:nvSpPr>
-          <p:cNvPr id="17" name="Shape 15"/>
-          <p:cNvSpPr/>
-          <p:nvPr/>
-        </p:nvSpPr>
-        <p:spPr>
-          <a:xfrm>
-            <a:off x="4663440" y="1874520"/>
-            <a:ext cx="3657600" cy="365760"/>
-          </a:xfrm>
-          <a:prstGeom prst="rect">
-            <a:avLst/>
-          </a:prstGeom>
-          <a:solidFill>
-            <a:srgbClr val="4FC3F7"/>
-          </a:solidFill>
-          <a:ln w="12700">
-            <a:solidFill>
-              <a:srgbClr val="4FC3F7"/>
-            </a:solidFill>
-            <a:prstDash val="solid"/>
-          </a:ln>
-        </p:spPr>
-      </p:sp>
-      <p:sp>
-        <p:nvSpPr>
-          <p:cNvPr id="18" name="Text 16"/>
-          <p:cNvSpPr/>
-          <p:nvPr/>
-        </p:nvSpPr>
-        <p:spPr>
-          <a:xfrm>
-            <a:off x="4754880" y="1892808"/>
-            <a:ext cx="3474720" cy="329184"/>
-          </a:xfrm>
-          <a:prstGeom prst="rect">
-            <a:avLst/>
-          </a:prstGeom>
-          <a:noFill/>
-          <a:ln/>
-        </p:spPr>
-        <p:txBody>
-          <a:bodyPr wrap="square" lIns="0" tIns="0" rIns="0" bIns="0" rtlCol="0" anchor="ctr"/>
-          <a:lstStyle/>
-          <a:p>
-            <a:pPr indent="0" marL="0">
-              <a:buNone/>
-            </a:pPr>
-            <a:r>
-              <a:rPr lang="en-US" sz="1200" b="1" dirty="0">
-                <a:solidFill>
-                  <a:srgbClr val="0D1B2A"/>
-                </a:solidFill>
-                <a:latin typeface="Calibri" pitchFamily="34" charset="0"/>
-                <a:ea typeface="Calibri" pitchFamily="34" charset="-122"/>
-                <a:cs typeface="Calibri" pitchFamily="34" charset="-120"/>
-              </a:rPr>
-              <a:t>BFS (Fewest Stops)</a:t>
-            </a:r>
-            <a:endParaRPr lang="en-US" sz="1200" dirty="0"/>
-          </a:p>
-        </p:txBody>
-      </p:sp>
-      <p:sp>
-        <p:nvSpPr>
-          <p:cNvPr id="19" name="Text 17"/>
-          <p:cNvSpPr/>
-          <p:nvPr/>
-        </p:nvSpPr>
-        <p:spPr>
-          <a:xfrm>
-            <a:off x="4800600" y="2377440"/>
-            <a:ext cx="3383280" cy="731520"/>
-          </a:xfrm>
-          <a:prstGeom prst="rect">
-            <a:avLst/>
-          </a:prstGeom>
-          <a:noFill/>
-          <a:ln/>
-        </p:spPr>
-        <p:txBody>
-          <a:bodyPr wrap="square" lIns="0" tIns="0" rIns="0" bIns="0" rtlCol="0" anchor="ctr"/>
-          <a:lstStyle/>
-          <a:p>
-            <a:pPr indent="0" marL="0">
-              <a:buNone/>
-            </a:pPr>
-            <a:r>
-              <a:rPr lang="en-US" sz="1200" dirty="0">
-                <a:solidFill>
-                  <a:srgbClr val="FFFFFF"/>
-                </a:solidFill>
-                <a:latin typeface="Calibri" pitchFamily="34" charset="0"/>
-                <a:ea typeface="Calibri" pitchFamily="34" charset="-122"/>
-                <a:cs typeface="Calibri" pitchFamily="34" charset="-120"/>
-              </a:rPr>
-              <a:t>JFK → NRT</a:t>
-            </a:r>
-            <a:endParaRPr lang="en-US" sz="1200" dirty="0"/>
-          </a:p>
-        </p:txBody>
-      </p:sp>
-      <p:sp>
-        <p:nvSpPr>
-          <p:cNvPr id="20" name="Text 18"/>
-          <p:cNvSpPr/>
-          <p:nvPr/>
-        </p:nvSpPr>
-        <p:spPr>
-          <a:xfrm>
-            <a:off x="4800600" y="3200400"/>
-            <a:ext cx="3383280" cy="320040"/>
-          </a:xfrm>
-          <a:prstGeom prst="rect">
-            <a:avLst/>
-          </a:prstGeom>
-          <a:noFill/>
-          <a:ln/>
-        </p:spPr>
-        <p:txBody>
-          <a:bodyPr wrap="square" lIns="0" tIns="0" rIns="0" bIns="0" rtlCol="0" anchor="ctr"/>
-          <a:lstStyle/>
-          <a:p>
-            <a:pPr indent="0" marL="0">
-              <a:buNone/>
-            </a:pPr>
-            <a:r>
-              <a:rPr lang="en-US" sz="1100" i="1" dirty="0">
-                <a:solidFill>
-                  <a:srgbClr val="4FC3F7"/>
-                </a:solidFill>
-                <a:latin typeface="Calibri" pitchFamily="34" charset="0"/>
-                <a:ea typeface="Calibri" pitchFamily="34" charset="-122"/>
-                <a:cs typeface="Calibri" pitchFamily="34" charset="-120"/>
-              </a:rPr>
-              <a:t>10,838 km  |  direct</a:t>
-            </a:r>
-            <a:endParaRPr lang="en-US" sz="1100" dirty="0"/>
-          </a:p>
-        </p:txBody>
-      </p:sp>
-      <p:sp>
-        <p:nvSpPr>
-          <p:cNvPr id="21" name="Text 19"/>
-          <p:cNvSpPr/>
-          <p:nvPr/>
-        </p:nvSpPr>
-        <p:spPr>
-          <a:xfrm>
-            <a:off x="731520" y="4617720"/>
-            <a:ext cx="7772400" cy="320040"/>
-          </a:xfrm>
-          <a:prstGeom prst="rect">
-            <a:avLst/>
-          </a:prstGeom>
-          <a:noFill/>
-          <a:ln/>
-        </p:spPr>
-        <p:txBody>
-          <a:bodyPr wrap="square" lIns="0" tIns="0" rIns="0" bIns="0" rtlCol="0" anchor="ctr"/>
-          <a:lstStyle/>
-          <a:p>
-            <a:pPr indent="0" marL="0">
-              <a:buNone/>
-            </a:pPr>
-            <a:r>
-              <a:rPr lang="en-US" sz="1050" dirty="0">
-                <a:solidFill>
-                  <a:srgbClr val="8FA8C0"/>
-                </a:solidFill>
-                <a:latin typeface="Calibri" pitchFamily="34" charset="0"/>
-                <a:ea typeface="Calibri" pitchFamily="34" charset="-122"/>
-                <a:cs typeface="Calibri" pitchFamily="34" charset="-120"/>
-              </a:rPr>
               <a:t>→  Type any airport name or 3-letter code and compare both routes instantly</a:t>
             </a:r>
             <a:endParaRPr lang="en-US" sz="1050" dirty="0"/>
           </a:p>
         </p:txBody>
       </p:sp>
+      <p:pic>
+        <p:nvPicPr>
+          <p:cNvPr id="23" name="Picture 22">
+            <a:extLst>
+              <a:ext uri="{FF2B5EF4-FFF2-40B4-BE49-F238E27FC236}">
+                <a16:creationId xmlns:a16="http://schemas.microsoft.com/office/drawing/2014/main" id="{F3D54D98-E586-852A-D178-27A7B31B3B89}"/>
+              </a:ext>
+            </a:extLst>
+          </p:cNvPr>
+          <p:cNvPicPr>
+            <a:picLocks noChangeAspect="1"/>
+          </p:cNvPicPr>
+          <p:nvPr/>
+        </p:nvPicPr>
+        <p:blipFill>
+          <a:blip r:embed="rId3"/>
+          <a:srcRect b="2061"/>
+          <a:stretch>
+            <a:fillRect/>
+          </a:stretch>
+        </p:blipFill>
+        <p:spPr>
+          <a:xfrm>
+            <a:off x="551278" y="1072587"/>
+            <a:ext cx="7952642" cy="3545134"/>
+          </a:xfrm>
+          <a:prstGeom prst="rect">
+            <a:avLst/>
+          </a:prstGeom>
+        </p:spPr>
+      </p:pic>
     </p:spTree>
   </p:cSld>
   <p:clrMapOvr>
@@ -4121,6 +4078,7 @@
         <a:solidFill>
           <a:srgbClr val="E8F1F8"/>
         </a:solidFill>
+        <a:effectLst/>
       </p:bgPr>
     </p:bg>
     <p:spTree>
@@ -4158,7 +4116,7 @@
           <a:bodyPr wrap="square" lIns="0" tIns="0" rIns="0" bIns="0" rtlCol="0" anchor="ctr"/>
           <a:lstStyle/>
           <a:p>
-            <a:pPr indent="0" marL="0">
+            <a:pPr marL="0" indent="0">
               <a:buNone/>
             </a:pPr>
             <a:r>
@@ -4200,6 +4158,13 @@
             <a:prstDash val="solid"/>
           </a:ln>
         </p:spPr>
+        <p:txBody>
+          <a:bodyPr/>
+          <a:lstStyle/>
+          <a:p>
+            <a:endParaRPr lang="en-US"/>
+          </a:p>
+        </p:txBody>
       </p:sp>
       <p:sp>
         <p:nvSpPr>
@@ -4222,7 +4187,7 @@
           <a:bodyPr wrap="square" lIns="0" tIns="0" rIns="0" bIns="0" rtlCol="0" anchor="ctr"/>
           <a:lstStyle/>
           <a:p>
-            <a:pPr indent="0" marL="0">
+            <a:pPr marL="0" indent="0">
               <a:buNone/>
             </a:pPr>
             <a:r>
@@ -4264,13 +4229,20 @@
             <a:prstDash val="solid"/>
           </a:ln>
           <a:effectLst>
-            <a:outerShdw sx="100000" sy="100000" kx="0" ky="0" algn="bl" rotWithShape="0" blurRad="76200" dist="25400" dir="8100000">
+            <a:outerShdw blurRad="76200" dist="25400" dir="8100000" algn="bl" rotWithShape="0">
               <a:srgbClr val="000000">
                 <a:alpha val="8000"/>
               </a:srgbClr>
             </a:outerShdw>
           </a:effectLst>
         </p:spPr>
+        <p:txBody>
+          <a:bodyPr/>
+          <a:lstStyle/>
+          <a:p>
+            <a:endParaRPr lang="en-US"/>
+          </a:p>
+        </p:txBody>
       </p:sp>
       <p:sp>
         <p:nvSpPr>
@@ -4293,7 +4265,7 @@
           <a:bodyPr wrap="square" lIns="0" tIns="0" rIns="0" bIns="0" rtlCol="0" anchor="ctr"/>
           <a:lstStyle/>
           <a:p>
-            <a:pPr algn="ctr" indent="0" marL="0">
+            <a:pPr marL="0" indent="0" algn="ctr">
               <a:buNone/>
             </a:pPr>
             <a:r>
@@ -4329,7 +4301,7 @@
           <a:bodyPr wrap="square" lIns="0" tIns="0" rIns="0" bIns="0" rtlCol="0" anchor="ctr"/>
           <a:lstStyle/>
           <a:p>
-            <a:pPr indent="0" marL="0">
+            <a:pPr marL="0" indent="0">
               <a:buNone/>
             </a:pPr>
             <a:r>
@@ -4368,7 +4340,7 @@
           <a:bodyPr wrap="square" lIns="0" tIns="0" rIns="0" bIns="0" rtlCol="0" anchor="ctr"/>
           <a:lstStyle/>
           <a:p>
-            <a:pPr indent="0" marL="0">
+            <a:pPr marL="0" indent="0">
               <a:buNone/>
             </a:pPr>
             <a:r>
@@ -4410,13 +4382,20 @@
             <a:prstDash val="solid"/>
           </a:ln>
           <a:effectLst>
-            <a:outerShdw sx="100000" sy="100000" kx="0" ky="0" algn="bl" rotWithShape="0" blurRad="76200" dist="25400" dir="8100000">
+            <a:outerShdw blurRad="76200" dist="25400" dir="8100000" algn="bl" rotWithShape="0">
               <a:srgbClr val="000000">
                 <a:alpha val="8000"/>
               </a:srgbClr>
             </a:outerShdw>
           </a:effectLst>
         </p:spPr>
+        <p:txBody>
+          <a:bodyPr/>
+          <a:lstStyle/>
+          <a:p>
+            <a:endParaRPr lang="en-US"/>
+          </a:p>
+        </p:txBody>
       </p:sp>
       <p:sp>
         <p:nvSpPr>
@@ -4439,7 +4418,7 @@
           <a:bodyPr wrap="square" lIns="0" tIns="0" rIns="0" bIns="0" rtlCol="0" anchor="ctr"/>
           <a:lstStyle/>
           <a:p>
-            <a:pPr algn="ctr" indent="0" marL="0">
+            <a:pPr marL="0" indent="0" algn="ctr">
               <a:buNone/>
             </a:pPr>
             <a:r>
@@ -4475,7 +4454,7 @@
           <a:bodyPr wrap="square" lIns="0" tIns="0" rIns="0" bIns="0" rtlCol="0" anchor="ctr"/>
           <a:lstStyle/>
           <a:p>
-            <a:pPr indent="0" marL="0">
+            <a:pPr marL="0" indent="0">
               <a:buNone/>
             </a:pPr>
             <a:r>
@@ -4514,7 +4493,7 @@
           <a:bodyPr wrap="square" lIns="0" tIns="0" rIns="0" bIns="0" rtlCol="0" anchor="ctr"/>
           <a:lstStyle/>
           <a:p>
-            <a:pPr indent="0" marL="0">
+            <a:pPr marL="0" indent="0">
               <a:buNone/>
             </a:pPr>
             <a:r>
@@ -4556,13 +4535,20 @@
             <a:prstDash val="solid"/>
           </a:ln>
           <a:effectLst>
-            <a:outerShdw sx="100000" sy="100000" kx="0" ky="0" algn="bl" rotWithShape="0" blurRad="76200" dist="25400" dir="8100000">
+            <a:outerShdw blurRad="76200" dist="25400" dir="8100000" algn="bl" rotWithShape="0">
               <a:srgbClr val="000000">
                 <a:alpha val="8000"/>
               </a:srgbClr>
             </a:outerShdw>
           </a:effectLst>
         </p:spPr>
+        <p:txBody>
+          <a:bodyPr/>
+          <a:lstStyle/>
+          <a:p>
+            <a:endParaRPr lang="en-US"/>
+          </a:p>
+        </p:txBody>
       </p:sp>
       <p:sp>
         <p:nvSpPr>
@@ -4585,7 +4571,7 @@
           <a:bodyPr wrap="square" lIns="0" tIns="0" rIns="0" bIns="0" rtlCol="0" anchor="ctr"/>
           <a:lstStyle/>
           <a:p>
-            <a:pPr algn="ctr" indent="0" marL="0">
+            <a:pPr marL="0" indent="0" algn="ctr">
               <a:buNone/>
             </a:pPr>
             <a:r>
@@ -4621,7 +4607,7 @@
           <a:bodyPr wrap="square" lIns="0" tIns="0" rIns="0" bIns="0" rtlCol="0" anchor="ctr"/>
           <a:lstStyle/>
           <a:p>
-            <a:pPr indent="0" marL="0">
+            <a:pPr marL="0" indent="0">
               <a:buNone/>
             </a:pPr>
             <a:r>
@@ -4660,7 +4646,7 @@
           <a:bodyPr wrap="square" lIns="0" tIns="0" rIns="0" bIns="0" rtlCol="0" anchor="ctr"/>
           <a:lstStyle/>
           <a:p>
-            <a:pPr indent="0" marL="0">
+            <a:pPr marL="0" indent="0">
               <a:buNone/>
             </a:pPr>
             <a:r>
@@ -4702,13 +4688,20 @@
             <a:prstDash val="solid"/>
           </a:ln>
           <a:effectLst>
-            <a:outerShdw sx="100000" sy="100000" kx="0" ky="0" algn="bl" rotWithShape="0" blurRad="76200" dist="25400" dir="8100000">
+            <a:outerShdw blurRad="76200" dist="25400" dir="8100000" algn="bl" rotWithShape="0">
               <a:srgbClr val="000000">
                 <a:alpha val="8000"/>
               </a:srgbClr>
             </a:outerShdw>
           </a:effectLst>
         </p:spPr>
+        <p:txBody>
+          <a:bodyPr/>
+          <a:lstStyle/>
+          <a:p>
+            <a:endParaRPr lang="en-US"/>
+          </a:p>
+        </p:txBody>
       </p:sp>
       <p:sp>
         <p:nvSpPr>
@@ -4731,7 +4724,7 @@
           <a:bodyPr wrap="square" lIns="0" tIns="0" rIns="0" bIns="0" rtlCol="0" anchor="ctr"/>
           <a:lstStyle/>
           <a:p>
-            <a:pPr algn="ctr" indent="0" marL="0">
+            <a:pPr marL="0" indent="0" algn="ctr">
               <a:buNone/>
             </a:pPr>
             <a:r>
@@ -4767,7 +4760,7 @@
           <a:bodyPr wrap="square" lIns="0" tIns="0" rIns="0" bIns="0" rtlCol="0" anchor="ctr"/>
           <a:lstStyle/>
           <a:p>
-            <a:pPr indent="0" marL="0">
+            <a:pPr marL="0" indent="0">
               <a:buNone/>
             </a:pPr>
             <a:r>
@@ -4806,7 +4799,7 @@
           <a:bodyPr wrap="square" lIns="0" tIns="0" rIns="0" bIns="0" rtlCol="0" anchor="ctr"/>
           <a:lstStyle/>
           <a:p>
-            <a:pPr indent="0" marL="0">
+            <a:pPr marL="0" indent="0">
               <a:buNone/>
             </a:pPr>
             <a:r>
@@ -4840,6 +4833,7 @@
         <a:solidFill>
           <a:srgbClr val="0D1B2A"/>
         </a:solidFill>
+        <a:effectLst/>
       </p:bgPr>
     </p:bg>
     <p:spTree>
@@ -4882,6 +4876,13 @@
             <a:prstDash val="solid"/>
           </a:ln>
         </p:spPr>
+        <p:txBody>
+          <a:bodyPr/>
+          <a:lstStyle/>
+          <a:p>
+            <a:endParaRPr lang="en-US"/>
+          </a:p>
+        </p:txBody>
       </p:sp>
       <p:sp>
         <p:nvSpPr>
@@ -4904,7 +4905,7 @@
           <a:bodyPr wrap="square" lIns="0" tIns="0" rIns="0" bIns="0" rtlCol="0" anchor="ctr"/>
           <a:lstStyle/>
           <a:p>
-            <a:pPr indent="0" marL="0">
+            <a:pPr marL="0" indent="0">
               <a:buNone/>
             </a:pPr>
             <a:r>
@@ -4946,6 +4947,13 @@
             <a:prstDash val="solid"/>
           </a:ln>
         </p:spPr>
+        <p:txBody>
+          <a:bodyPr/>
+          <a:lstStyle/>
+          <a:p>
+            <a:endParaRPr lang="en-US"/>
+          </a:p>
+        </p:txBody>
       </p:sp>
       <p:sp>
         <p:nvSpPr>
@@ -4971,6 +4979,13 @@
             <a:prstDash val="solid"/>
           </a:ln>
         </p:spPr>
+        <p:txBody>
+          <a:bodyPr/>
+          <a:lstStyle/>
+          <a:p>
+            <a:endParaRPr lang="en-US"/>
+          </a:p>
+        </p:txBody>
       </p:sp>
       <p:sp>
         <p:nvSpPr>
@@ -4993,7 +5008,7 @@
           <a:bodyPr wrap="square" lIns="0" tIns="0" rIns="0" bIns="0" rtlCol="0" anchor="ctr"/>
           <a:lstStyle/>
           <a:p>
-            <a:pPr algn="ctr" indent="0" marL="0">
+            <a:pPr marL="0" indent="0" algn="ctr">
               <a:buNone/>
             </a:pPr>
             <a:r>
@@ -5029,7 +5044,7 @@
           <a:bodyPr wrap="square" lIns="0" tIns="0" rIns="0" bIns="0" rtlCol="0" anchor="ctr"/>
           <a:lstStyle/>
           <a:p>
-            <a:pPr indent="0" marL="0">
+            <a:pPr marL="0" indent="0">
               <a:buNone/>
             </a:pPr>
             <a:r>
@@ -5071,6 +5086,13 @@
             <a:prstDash val="solid"/>
           </a:ln>
         </p:spPr>
+        <p:txBody>
+          <a:bodyPr/>
+          <a:lstStyle/>
+          <a:p>
+            <a:endParaRPr lang="en-US"/>
+          </a:p>
+        </p:txBody>
       </p:sp>
       <p:sp>
         <p:nvSpPr>
@@ -5093,7 +5115,7 @@
           <a:bodyPr wrap="square" lIns="0" tIns="0" rIns="0" bIns="0" rtlCol="0" anchor="ctr"/>
           <a:lstStyle/>
           <a:p>
-            <a:pPr algn="ctr" indent="0" marL="0">
+            <a:pPr marL="0" indent="0" algn="ctr">
               <a:buNone/>
             </a:pPr>
             <a:r>
@@ -5129,7 +5151,7 @@
           <a:bodyPr wrap="square" lIns="0" tIns="0" rIns="0" bIns="0" rtlCol="0" anchor="ctr"/>
           <a:lstStyle/>
           <a:p>
-            <a:pPr indent="0" marL="0">
+            <a:pPr marL="0" indent="0">
               <a:buNone/>
             </a:pPr>
             <a:r>
@@ -5171,6 +5193,13 @@
             <a:prstDash val="solid"/>
           </a:ln>
         </p:spPr>
+        <p:txBody>
+          <a:bodyPr/>
+          <a:lstStyle/>
+          <a:p>
+            <a:endParaRPr lang="en-US"/>
+          </a:p>
+        </p:txBody>
       </p:sp>
       <p:sp>
         <p:nvSpPr>
@@ -5193,7 +5222,7 @@
           <a:bodyPr wrap="square" lIns="0" tIns="0" rIns="0" bIns="0" rtlCol="0" anchor="ctr"/>
           <a:lstStyle/>
           <a:p>
-            <a:pPr algn="ctr" indent="0" marL="0">
+            <a:pPr marL="0" indent="0" algn="ctr">
               <a:buNone/>
             </a:pPr>
             <a:r>
@@ -5229,7 +5258,7 @@
           <a:bodyPr wrap="square" lIns="0" tIns="0" rIns="0" bIns="0" rtlCol="0" anchor="ctr"/>
           <a:lstStyle/>
           <a:p>
-            <a:pPr indent="0" marL="0">
+            <a:pPr marL="0" indent="0">
               <a:buNone/>
             </a:pPr>
             <a:r>
@@ -5271,6 +5300,13 @@
             <a:prstDash val="solid"/>
           </a:ln>
         </p:spPr>
+        <p:txBody>
+          <a:bodyPr/>
+          <a:lstStyle/>
+          <a:p>
+            <a:endParaRPr lang="en-US"/>
+          </a:p>
+        </p:txBody>
       </p:sp>
       <p:sp>
         <p:nvSpPr>
@@ -5293,7 +5329,7 @@
           <a:bodyPr wrap="square" lIns="0" tIns="0" rIns="0" bIns="0" rtlCol="0" anchor="ctr"/>
           <a:lstStyle/>
           <a:p>
-            <a:pPr algn="ctr" indent="0" marL="0">
+            <a:pPr marL="0" indent="0" algn="ctr">
               <a:buNone/>
             </a:pPr>
             <a:r>
@@ -5329,7 +5365,7 @@
           <a:bodyPr wrap="square" lIns="0" tIns="0" rIns="0" bIns="0" rtlCol="0" anchor="ctr"/>
           <a:lstStyle/>
           <a:p>
-            <a:pPr indent="0" marL="0">
+            <a:pPr marL="0" indent="0">
               <a:buNone/>
             </a:pPr>
             <a:r>
@@ -5371,6 +5407,13 @@
             <a:prstDash val="solid"/>
           </a:ln>
         </p:spPr>
+        <p:txBody>
+          <a:bodyPr/>
+          <a:lstStyle/>
+          <a:p>
+            <a:endParaRPr lang="en-US"/>
+          </a:p>
+        </p:txBody>
       </p:sp>
       <p:sp>
         <p:nvSpPr>
@@ -5393,7 +5436,7 @@
           <a:bodyPr wrap="square" lIns="0" tIns="0" rIns="0" bIns="0" rtlCol="0" anchor="ctr"/>
           <a:lstStyle/>
           <a:p>
-            <a:pPr algn="ctr" indent="0" marL="0">
+            <a:pPr marL="0" indent="0" algn="ctr">
               <a:buNone/>
             </a:pPr>
             <a:r>
@@ -5429,7 +5472,7 @@
           <a:bodyPr wrap="square" lIns="0" tIns="0" rIns="0" bIns="0" rtlCol="0" anchor="ctr"/>
           <a:lstStyle/>
           <a:p>
-            <a:pPr indent="0" marL="0">
+            <a:pPr marL="0" indent="0">
               <a:buNone/>
             </a:pPr>
             <a:r>
@@ -5468,7 +5511,7 @@
           <a:bodyPr wrap="square" lIns="0" tIns="0" rIns="0" bIns="0" rtlCol="0" anchor="ctr"/>
           <a:lstStyle/>
           <a:p>
-            <a:pPr indent="0" marL="0">
+            <a:pPr marL="0" indent="0">
               <a:buNone/>
             </a:pPr>
             <a:r>
@@ -5787,4 +5830,319 @@
     </a:ext>
   </a:extLst>
 </a:theme>
+</file>
+
+<file path=ppt/theme/theme2.xml><?xml version="1.0" encoding="utf-8"?>
+<a:theme xmlns:a="http://schemas.openxmlformats.org/drawingml/2006/main" name="Office Theme">
+  <a:themeElements>
+    <a:clrScheme name="Office">
+      <a:dk1>
+        <a:sysClr val="windowText" lastClr="000000"/>
+      </a:dk1>
+      <a:lt1>
+        <a:sysClr val="window" lastClr="FFFFFF"/>
+      </a:lt1>
+      <a:dk2>
+        <a:srgbClr val="0E2841"/>
+      </a:dk2>
+      <a:lt2>
+        <a:srgbClr val="E8E8E8"/>
+      </a:lt2>
+      <a:accent1>
+        <a:srgbClr val="156082"/>
+      </a:accent1>
+      <a:accent2>
+        <a:srgbClr val="E97132"/>
+      </a:accent2>
+      <a:accent3>
+        <a:srgbClr val="196B24"/>
+      </a:accent3>
+      <a:accent4>
+        <a:srgbClr val="0F9ED5"/>
+      </a:accent4>
+      <a:accent5>
+        <a:srgbClr val="A02B93"/>
+      </a:accent5>
+      <a:accent6>
+        <a:srgbClr val="4EA72E"/>
+      </a:accent6>
+      <a:hlink>
+        <a:srgbClr val="467886"/>
+      </a:hlink>
+      <a:folHlink>
+        <a:srgbClr val="96607D"/>
+      </a:folHlink>
+    </a:clrScheme>
+    <a:fontScheme name="Office">
+      <a:majorFont>
+        <a:latin typeface="Aptos Display" panose="02110004020202020204"/>
+        <a:ea typeface=""/>
+        <a:cs typeface=""/>
+        <a:font script="Jpan" typeface="游ゴシック Light"/>
+        <a:font script="Hang" typeface="맑은 고딕"/>
+        <a:font script="Hans" typeface="等线 Light"/>
+        <a:font script="Hant" typeface="新細明體"/>
+        <a:font script="Arab" typeface="Times New Roman"/>
+        <a:font script="Hebr" typeface="Times New Roman"/>
+        <a:font script="Thai" typeface="Angsana New"/>
+        <a:font script="Ethi" typeface="Nyala"/>
+        <a:font script="Beng" typeface="Vrinda"/>
+        <a:font script="Gujr" typeface="Shruti"/>
+        <a:font script="Khmr" typeface="MoolBoran"/>
+        <a:font script="Knda" typeface="Tunga"/>
+        <a:font script="Guru" typeface="Raavi"/>
+        <a:font script="Cans" typeface="Euphemia"/>
+        <a:font script="Cher" typeface="Plantagenet Cherokee"/>
+        <a:font script="Yiii" typeface="Microsoft Yi Baiti"/>
+        <a:font script="Tibt" typeface="Microsoft Himalaya"/>
+        <a:font script="Thaa" typeface="MV Boli"/>
+        <a:font script="Deva" typeface="Mangal"/>
+        <a:font script="Telu" typeface="Gautami"/>
+        <a:font script="Taml" typeface="Latha"/>
+        <a:font script="Syrc" typeface="Estrangelo Edessa"/>
+        <a:font script="Orya" typeface="Kalinga"/>
+        <a:font script="Mlym" typeface="Kartika"/>
+        <a:font script="Laoo" typeface="DokChampa"/>
+        <a:font script="Sinh" typeface="Iskoola Pota"/>
+        <a:font script="Mong" typeface="Mongolian Baiti"/>
+        <a:font script="Viet" typeface="Times New Roman"/>
+        <a:font script="Uigh" typeface="Microsoft Uighur"/>
+        <a:font script="Geor" typeface="Sylfaen"/>
+        <a:font script="Armn" typeface="Arial"/>
+        <a:font script="Bugi" typeface="Leelawadee UI"/>
+        <a:font script="Bopo" typeface="Microsoft JhengHei"/>
+        <a:font script="Java" typeface="Javanese Text"/>
+        <a:font script="Lisu" typeface="Segoe UI"/>
+        <a:font script="Mymr" typeface="Myanmar Text"/>
+        <a:font script="Nkoo" typeface="Ebrima"/>
+        <a:font script="Olck" typeface="Nirmala UI"/>
+        <a:font script="Osma" typeface="Ebrima"/>
+        <a:font script="Phag" typeface="Phagspa"/>
+        <a:font script="Syrn" typeface="Estrangelo Edessa"/>
+        <a:font script="Syrj" typeface="Estrangelo Edessa"/>
+        <a:font script="Syre" typeface="Estrangelo Edessa"/>
+        <a:font script="Sora" typeface="Nirmala UI"/>
+        <a:font script="Tale" typeface="Microsoft Tai Le"/>
+        <a:font script="Talu" typeface="Microsoft New Tai Lue"/>
+        <a:font script="Tfng" typeface="Ebrima"/>
+      </a:majorFont>
+      <a:minorFont>
+        <a:latin typeface="Aptos" panose="02110004020202020204"/>
+        <a:ea typeface=""/>
+        <a:cs typeface=""/>
+        <a:font script="Jpan" typeface="游ゴシック"/>
+        <a:font script="Hang" typeface="맑은 고딕"/>
+        <a:font script="Hans" typeface="等线"/>
+        <a:font script="Hant" typeface="新細明體"/>
+        <a:font script="Arab" typeface="Arial"/>
+        <a:font script="Hebr" typeface="Arial"/>
+        <a:font script="Thai" typeface="Cordia New"/>
+        <a:font script="Ethi" typeface="Nyala"/>
+        <a:font script="Beng" typeface="Vrinda"/>
+        <a:font script="Gujr" typeface="Shruti"/>
+        <a:font script="Khmr" typeface="DaunPenh"/>
+        <a:font script="Knda" typeface="Tunga"/>
+        <a:font script="Guru" typeface="Raavi"/>
+        <a:font script="Cans" typeface="Euphemia"/>
+        <a:font script="Cher" typeface="Plantagenet Cherokee"/>
+        <a:font script="Yiii" typeface="Microsoft Yi Baiti"/>
+        <a:font script="Tibt" typeface="Microsoft Himalaya"/>
+        <a:font script="Thaa" typeface="MV Boli"/>
+        <a:font script="Deva" typeface="Mangal"/>
+        <a:font script="Telu" typeface="Gautami"/>
+        <a:font script="Taml" typeface="Latha"/>
+        <a:font script="Syrc" typeface="Estrangelo Edessa"/>
+        <a:font script="Orya" typeface="Kalinga"/>
+        <a:font script="Mlym" typeface="Kartika"/>
+        <a:font script="Laoo" typeface="DokChampa"/>
+        <a:font script="Sinh" typeface="Iskoola Pota"/>
+        <a:font script="Mong" typeface="Mongolian Baiti"/>
+        <a:font script="Viet" typeface="Arial"/>
+        <a:font script="Uigh" typeface="Microsoft Uighur"/>
+        <a:font script="Geor" typeface="Sylfaen"/>
+        <a:font script="Armn" typeface="Arial"/>
+        <a:font script="Bugi" typeface="Leelawadee UI"/>
+        <a:font script="Bopo" typeface="Microsoft JhengHei"/>
+        <a:font script="Java" typeface="Javanese Text"/>
+        <a:font script="Lisu" typeface="Segoe UI"/>
+        <a:font script="Mymr" typeface="Myanmar Text"/>
+        <a:font script="Nkoo" typeface="Ebrima"/>
+        <a:font script="Olck" typeface="Nirmala UI"/>
+        <a:font script="Osma" typeface="Ebrima"/>
+        <a:font script="Phag" typeface="Phagspa"/>
+        <a:font script="Syrn" typeface="Estrangelo Edessa"/>
+        <a:font script="Syrj" typeface="Estrangelo Edessa"/>
+        <a:font script="Syre" typeface="Estrangelo Edessa"/>
+        <a:font script="Sora" typeface="Nirmala UI"/>
+        <a:font script="Tale" typeface="Microsoft Tai Le"/>
+        <a:font script="Talu" typeface="Microsoft New Tai Lue"/>
+        <a:font script="Tfng" typeface="Ebrima"/>
+      </a:minorFont>
+    </a:fontScheme>
+    <a:fmtScheme name="Office">
+      <a:fillStyleLst>
+        <a:solidFill>
+          <a:schemeClr val="phClr"/>
+        </a:solidFill>
+        <a:gradFill rotWithShape="1">
+          <a:gsLst>
+            <a:gs pos="0">
+              <a:schemeClr val="phClr">
+                <a:lumMod val="110000"/>
+                <a:satMod val="105000"/>
+                <a:tint val="67000"/>
+              </a:schemeClr>
+            </a:gs>
+            <a:gs pos="50000">
+              <a:schemeClr val="phClr">
+                <a:lumMod val="105000"/>
+                <a:satMod val="103000"/>
+                <a:tint val="73000"/>
+              </a:schemeClr>
+            </a:gs>
+            <a:gs pos="100000">
+              <a:schemeClr val="phClr">
+                <a:lumMod val="105000"/>
+                <a:satMod val="109000"/>
+                <a:tint val="81000"/>
+              </a:schemeClr>
+            </a:gs>
+          </a:gsLst>
+          <a:lin ang="5400000" scaled="0"/>
+        </a:gradFill>
+        <a:gradFill rotWithShape="1">
+          <a:gsLst>
+            <a:gs pos="0">
+              <a:schemeClr val="phClr">
+                <a:satMod val="103000"/>
+                <a:lumMod val="102000"/>
+                <a:tint val="94000"/>
+              </a:schemeClr>
+            </a:gs>
+            <a:gs pos="50000">
+              <a:schemeClr val="phClr">
+                <a:satMod val="110000"/>
+                <a:lumMod val="100000"/>
+                <a:shade val="100000"/>
+              </a:schemeClr>
+            </a:gs>
+            <a:gs pos="100000">
+              <a:schemeClr val="phClr">
+                <a:lumMod val="99000"/>
+                <a:satMod val="120000"/>
+                <a:shade val="78000"/>
+              </a:schemeClr>
+            </a:gs>
+          </a:gsLst>
+          <a:lin ang="5400000" scaled="0"/>
+        </a:gradFill>
+      </a:fillStyleLst>
+      <a:lnStyleLst>
+        <a:ln w="12700" cap="flat" cmpd="sng" algn="ctr">
+          <a:solidFill>
+            <a:schemeClr val="phClr"/>
+          </a:solidFill>
+          <a:prstDash val="solid"/>
+          <a:miter lim="800000"/>
+        </a:ln>
+        <a:ln w="19050" cap="flat" cmpd="sng" algn="ctr">
+          <a:solidFill>
+            <a:schemeClr val="phClr"/>
+          </a:solidFill>
+          <a:prstDash val="solid"/>
+          <a:miter lim="800000"/>
+        </a:ln>
+        <a:ln w="25400" cap="flat" cmpd="sng" algn="ctr">
+          <a:solidFill>
+            <a:schemeClr val="phClr"/>
+          </a:solidFill>
+          <a:prstDash val="solid"/>
+          <a:miter lim="800000"/>
+        </a:ln>
+      </a:lnStyleLst>
+      <a:effectStyleLst>
+        <a:effectStyle>
+          <a:effectLst/>
+        </a:effectStyle>
+        <a:effectStyle>
+          <a:effectLst/>
+        </a:effectStyle>
+        <a:effectStyle>
+          <a:effectLst>
+            <a:outerShdw blurRad="57150" dist="19050" dir="5400000" algn="ctr" rotWithShape="0">
+              <a:srgbClr val="000000">
+                <a:alpha val="63000"/>
+              </a:srgbClr>
+            </a:outerShdw>
+          </a:effectLst>
+        </a:effectStyle>
+      </a:effectStyleLst>
+      <a:bgFillStyleLst>
+        <a:solidFill>
+          <a:schemeClr val="phClr"/>
+        </a:solidFill>
+        <a:solidFill>
+          <a:schemeClr val="phClr">
+            <a:tint val="95000"/>
+            <a:satMod val="170000"/>
+          </a:schemeClr>
+        </a:solidFill>
+        <a:gradFill rotWithShape="1">
+          <a:gsLst>
+            <a:gs pos="0">
+              <a:schemeClr val="phClr">
+                <a:tint val="93000"/>
+                <a:satMod val="150000"/>
+                <a:shade val="98000"/>
+                <a:lumMod val="102000"/>
+              </a:schemeClr>
+            </a:gs>
+            <a:gs pos="50000">
+              <a:schemeClr val="phClr">
+                <a:tint val="98000"/>
+                <a:satMod val="130000"/>
+                <a:shade val="90000"/>
+                <a:lumMod val="103000"/>
+              </a:schemeClr>
+            </a:gs>
+            <a:gs pos="100000">
+              <a:schemeClr val="phClr">
+                <a:shade val="63000"/>
+                <a:satMod val="120000"/>
+              </a:schemeClr>
+            </a:gs>
+          </a:gsLst>
+          <a:lin ang="5400000" scaled="0"/>
+        </a:gradFill>
+      </a:bgFillStyleLst>
+    </a:fmtScheme>
+  </a:themeElements>
+  <a:objectDefaults>
+    <a:lnDef>
+      <a:spPr/>
+      <a:bodyPr/>
+      <a:lstStyle/>
+      <a:style>
+        <a:lnRef idx="2">
+          <a:schemeClr val="accent1"/>
+        </a:lnRef>
+        <a:fillRef idx="0">
+          <a:schemeClr val="accent1"/>
+        </a:fillRef>
+        <a:effectRef idx="1">
+          <a:schemeClr val="accent1"/>
+        </a:effectRef>
+        <a:fontRef idx="minor">
+          <a:schemeClr val="tx1"/>
+        </a:fontRef>
+      </a:style>
+    </a:lnDef>
+  </a:objectDefaults>
+  <a:extraClrSchemeLst/>
+  <a:extLst>
+    <a:ext uri="{05A4C25C-085E-4340-85A3-A5531E510DB2}">
+      <thm15:themeFamily xmlns:thm15="http://schemas.microsoft.com/office/thememl/2012/main" name="Office Theme" id="{2E142A2C-CD16-42D6-873A-C26D2A0506FA}" vid="{1BDDFF52-6CD6-40A5-AB3C-68EB2F1E4D0A}"/>
+    </a:ext>
+  </a:extLst>
+</a:theme>
 </file>
</xml_diff>